<commit_message>
Remove speaker notes from the Grade 1 and Grade 2 reading decks.
Co-authored-by: Cursor <cursoragent@cursor.com>
</commit_message>
<xml_diff>
--- a/Grade1_Bunny_Reading_Adventure_60min.pptx
+++ b/Grade1_Bunny_Reading_Adventure_60min.pptx
@@ -529,47 +529,7 @@
         <p:txBody>
           <a:bodyPr/>
           <a:lstStyle/>
-          <a:p>
-            <a:r>
-              <a:t>⏱ TIME: 0–5 min     |     READING MODE: No reading required</a:t>
-            </a:r>
-          </a:p>
           <a:p/>
-          <a:p>
-            <a:r>
-              <a:t>WHAT TO SAY: Hi! I am so happy to see you today. Look who came to class — it's Bunny! Bunny loves to read, and Bunny needs a reading buddy. That's going to be you.</a:t>
-            </a:r>
-          </a:p>
-          <a:p/>
-          <a:p>
-            <a:r>
-              <a:t>QUESTION TO ASK: Are you ready to be a Reading Explorer with Bunny?</a:t>
-            </a:r>
-          </a:p>
-          <a:p/>
-          <a:p>
-            <a:r>
-              <a:t>EXPECTED RESPONSE: A smile, a nod, or 'yes'. Any response is a win.</a:t>
-            </a:r>
-          </a:p>
-          <a:p/>
-          <a:p>
-            <a:r>
-              <a:t>IF THE CHILD STRUGGLES: If the child is shy, wave to Bunny yourself and say 'You can just wave hello.'</a:t>
-            </a:r>
-          </a:p>
-          <a:p/>
-          <a:p>
-            <a:r>
-              <a:t>PRAISE: I am so glad you are here. Bunny is excited too!</a:t>
-            </a:r>
-          </a:p>
-          <a:p/>
-          <a:p>
-            <a:r>
-              <a:t>NEVER say "Wrong." Say "Let's try it together," break the word into sounds, blend them, then ask the child to repeat it successfully.</a:t>
-            </a:r>
-          </a:p>
         </p:txBody>
       </p:sp>
       <p:sp>
@@ -635,47 +595,7 @@
         <p:txBody>
           <a:bodyPr/>
           <a:lstStyle/>
-          <a:p>
-            <a:r>
-              <a:t>⏱ TIME: 20–28 min     |     READING MODE: Child reads the word aloud after pointing</a:t>
-            </a:r>
-          </a:p>
           <a:p/>
-          <a:p>
-            <a:r>
-              <a:t>WHAT TO SAY: Bunny is hungry and only eats the right word! Look at the picture, then find the word that matches. Point to it and read it out loud.</a:t>
-            </a:r>
-          </a:p>
-          <a:p/>
-          <a:p>
-            <a:r>
-              <a:t>QUESTION TO ASK: Bunny wants the word CAT — can you find it?</a:t>
-            </a:r>
-          </a:p>
-          <a:p/>
-          <a:p>
-            <a:r>
-              <a:t>EXPECTED RESPONSE: CAT  •  SUN  •  DOG  •  PIG  •  HEN</a:t>
-            </a:r>
-          </a:p>
-          <a:p/>
-          <a:p>
-            <a:r>
-              <a:t>IF THE CHILD STRUGGLES: Ask what sound the word starts with, then look for that letter in the choices. Cover one wrong word so only two remain.</a:t>
-            </a:r>
-          </a:p>
-          <a:p/>
-          <a:p>
-            <a:r>
-              <a:t>PRAISE: You found it! Bunny says thank you. Munch munch!</a:t>
-            </a:r>
-          </a:p>
-          <a:p/>
-          <a:p>
-            <a:r>
-              <a:t>NEVER say "Wrong." Say "Let's try it together," break the word into sounds, blend them, then ask the child to repeat it successfully.</a:t>
-            </a:r>
-          </a:p>
         </p:txBody>
       </p:sp>
       <p:sp>
@@ -741,47 +661,7 @@
         <p:txBody>
           <a:bodyPr/>
           <a:lstStyle/>
-          <a:p>
-            <a:r>
-              <a:t>⏱ TIME: 20–28 min     |     READING MODE: Child reads each word after matching</a:t>
-            </a:r>
-          </a:p>
           <a:p/>
-          <a:p>
-            <a:r>
-              <a:t>WHAT TO SAY: The pictures are on top and the words are on the bottom, but they are all mixed up. Point to the cat, then find the word CAT.</a:t>
-            </a:r>
-          </a:p>
-          <a:p/>
-          <a:p>
-            <a:r>
-              <a:t>QUESTION TO ASK: Which word goes with this picture?</a:t>
-            </a:r>
-          </a:p>
-          <a:p/>
-          <a:p>
-            <a:r>
-              <a:t>EXPECTED RESPONSE: 🐱 = CAT (3rd word)  •  ☀️ = SUN (4th)  •  🐷 = PIG (2nd)  •  🐶 = DOG (1st)</a:t>
-            </a:r>
-          </a:p>
-          <a:p/>
-          <a:p>
-            <a:r>
-              <a:t>IF THE CHILD STRUGGLES: Ask for the first sound of the picture word, then hunt for that letter in the word cards.</a:t>
-            </a:r>
-          </a:p>
-          <a:p/>
-          <a:p>
-            <a:r>
-              <a:t>PRAISE: Four out of four! Excellent matching.</a:t>
-            </a:r>
-          </a:p>
-          <a:p/>
-          <a:p>
-            <a:r>
-              <a:t>NEVER say "Wrong." Say "Let's try it together," break the word into sounds, blend them, then ask the child to repeat it successfully.</a:t>
-            </a:r>
-          </a:p>
         </p:txBody>
       </p:sp>
       <p:sp>
@@ -847,47 +727,7 @@
         <p:txBody>
           <a:bodyPr/>
           <a:lstStyle/>
-          <a:p>
-            <a:r>
-              <a:t>⏱ TIME: 28–35 min     |     READING MODE: Look and say, teacher models first</a:t>
-            </a:r>
-          </a:p>
           <a:p/>
-          <a:p>
-            <a:r>
-              <a:t>WHAT TO SAY: These are special words. We do not sound them out — we just learn them by sight, like knowing a friend's face. This one says THE. Your turn: THE.</a:t>
-            </a:r>
-          </a:p>
-          <a:p/>
-          <a:p>
-            <a:r>
-              <a:t>QUESTION TO ASK: What does this word say?</a:t>
-            </a:r>
-          </a:p>
-          <a:p/>
-          <a:p>
-            <a:r>
-              <a:t>EXPECTED RESPONSE: I, am, a  →  the, is, my  →  can, see</a:t>
-            </a:r>
-          </a:p>
-          <a:p/>
-          <a:p>
-            <a:r>
-              <a:t>IF THE CHILD STRUGGLES: Cover Sets 2 and 3 with a sheet of paper. Teach Set 1 only, three times each, and reveal the next set only when Set 1 is solid. Two words truly known beats eight half-known.</a:t>
-            </a:r>
-          </a:p>
-          <a:p/>
-          <a:p>
-            <a:r>
-              <a:t>PRAISE: You just KNEW that word without sounding it out!</a:t>
-            </a:r>
-          </a:p>
-          <a:p/>
-          <a:p>
-            <a:r>
-              <a:t>NEVER say "Wrong." Say "Let's try it together," break the word into sounds, blend them, then ask the child to repeat it successfully.</a:t>
-            </a:r>
-          </a:p>
         </p:txBody>
       </p:sp>
       <p:sp>
@@ -953,47 +793,7 @@
         <p:txBody>
           <a:bodyPr/>
           <a:lstStyle/>
-          <a:p>
-            <a:r>
-              <a:t>⏱ TIME: 28–35 min     |     READING MODE: Child points, then says the word</a:t>
-            </a:r>
-          </a:p>
           <a:p/>
-          <a:p>
-            <a:r>
-              <a:t>WHAT TO SAY: Can you catch the word I? Look at all four words and point to the one that says I.</a:t>
-            </a:r>
-          </a:p>
-          <a:p/>
-          <a:p>
-            <a:r>
-              <a:t>QUESTION TO ASK: Can you find the word AM? Where is THE?</a:t>
-            </a:r>
-          </a:p>
-          <a:p/>
-          <a:p>
-            <a:r>
-              <a:t>EXPECTED RESPONSE: 1. I (2nd)   2. am (2nd)   3. the (2nd)</a:t>
-            </a:r>
-          </a:p>
-          <a:p/>
-          <a:p>
-            <a:r>
-              <a:t>IF THE CHILD STRUGGLES: Say the word again slowly, then cover two wrong choices with your fingers so only two remain.</a:t>
-            </a:r>
-          </a:p>
-          <a:p/>
-          <a:p>
-            <a:r>
-              <a:t>PRAISE: You caught it! Nice reading.</a:t>
-            </a:r>
-          </a:p>
-          <a:p/>
-          <a:p>
-            <a:r>
-              <a:t>NEVER say "Wrong." Say "Let's try it together," break the word into sounds, blend them, then ask the child to repeat it successfully.</a:t>
-            </a:r>
-          </a:p>
         </p:txBody>
       </p:sp>
       <p:sp>
@@ -1059,47 +859,7 @@
         <p:txBody>
           <a:bodyPr/>
           <a:lstStyle/>
-          <a:p>
-            <a:r>
-              <a:t>⏱ TIME: 28–35 min     |     READING MODE: Child points, then says the word</a:t>
-            </a:r>
-          </a:p>
           <a:p/>
-          <a:p>
-            <a:r>
-              <a:t>WHAT TO SAY: These are tricky ones — they all start the same way! Look at the whole word, not just the first letter. Can you find CAN?</a:t>
-            </a:r>
-          </a:p>
-          <a:p/>
-          <a:p>
-            <a:r>
-              <a:t>QUESTION TO ASK: Where is MY? Can you find SEE?</a:t>
-            </a:r>
-          </a:p>
-          <a:p/>
-          <a:p>
-            <a:r>
-              <a:t>EXPECTED RESPONSE: 4. can (1st)   5. my (2nd)   6. see (2nd)</a:t>
-            </a:r>
-          </a:p>
-          <a:p/>
-          <a:p>
-            <a:r>
-              <a:t>IF THE CHILD STRUGGLES: Read all four choices aloud yourself, then ask again. Point out the last letter as the clue that makes them different.</a:t>
-            </a:r>
-          </a:p>
-          <a:p/>
-          <a:p>
-            <a:r>
-              <a:t>PRAISE: Those tricky words did not fool you!</a:t>
-            </a:r>
-          </a:p>
-          <a:p/>
-          <a:p>
-            <a:r>
-              <a:t>NEVER say "Wrong." Say "Let's try it together," break the word into sounds, blend them, then ask the child to repeat it successfully.</a:t>
-            </a:r>
-          </a:p>
         </p:txBody>
       </p:sp>
       <p:sp>
@@ -1165,47 +925,7 @@
         <p:txBody>
           <a:bodyPr/>
           <a:lstStyle/>
-          <a:p>
-            <a:r>
-              <a:t>⏱ TIME: 35–38 min     |     READING MODE: Movement plus quick word pointing</a:t>
-            </a:r>
-          </a:p>
           <a:p/>
-          <a:p>
-            <a:r>
-              <a:t>WHAT TO SAY: Time to wiggle! But only move if Bunny says. Bunny says touch your nose! Bunny says make the /m/ sound!</a:t>
-            </a:r>
-          </a:p>
-          <a:p/>
-          <a:p>
-            <a:r>
-              <a:t>QUESTION TO ASK: Bunny says point to the letter B. Bunny says read the word CAT.</a:t>
-            </a:r>
-          </a:p>
-          <a:p/>
-          <a:p>
-            <a:r>
-              <a:t>EXPECTED RESPONSE: The child follows the commands and points to the right letter or word.</a:t>
-            </a:r>
-          </a:p>
-          <a:p/>
-          <a:p>
-            <a:r>
-              <a:t>IF THE CHILD STRUGGLES: Do the movement together the first time. If they move when you did not say 'Bunny says', laugh it off — this is a rest, not a test.</a:t>
-            </a:r>
-          </a:p>
-          <a:p/>
-          <a:p>
-            <a:r>
-              <a:t>PRAISE: You are so quick! Ready for some reading?</a:t>
-            </a:r>
-          </a:p>
-          <a:p/>
-          <a:p>
-            <a:r>
-              <a:t>NEVER say "Wrong." Say "Let's try it together," break the word into sounds, blend them, then ask the child to repeat it successfully.</a:t>
-            </a:r>
-          </a:p>
         </p:txBody>
       </p:sp>
       <p:sp>
@@ -1271,47 +991,7 @@
         <p:txBody>
           <a:bodyPr/>
           <a:lstStyle/>
-          <a:p>
-            <a:r>
-              <a:t>⏱ TIME: 38–45 min     |     READING MODE: I DO → WE DO → YOU DO</a:t>
-            </a:r>
-          </a:p>
           <a:p/>
-          <a:p>
-            <a:r>
-              <a:t>WHAT TO SAY: Now we put words together to make a sentence. Watch my finger. I... am... Sam. Now let's read it together.</a:t>
-            </a:r>
-          </a:p>
-          <a:p/>
-          <a:p>
-            <a:r>
-              <a:t>QUESTION TO ASK: Can you read it with me? Now can you try by yourself?</a:t>
-            </a:r>
-          </a:p>
-          <a:p/>
-          <a:p>
-            <a:r>
-              <a:t>EXPECTED RESPONSE: I am Sam.</a:t>
-            </a:r>
-          </a:p>
-          <a:p/>
-          <a:p>
-            <a:r>
-              <a:t>IF THE CHILD STRUGGLES: Read the first two words and let the child finish the last one. Build up backwards from the end of the sentence.</a:t>
-            </a:r>
-          </a:p>
-          <a:p/>
-          <a:p>
-            <a:r>
-              <a:t>PRAISE: You read a whole sentence! That is a big jump from words.</a:t>
-            </a:r>
-          </a:p>
-          <a:p/>
-          <a:p>
-            <a:r>
-              <a:t>NEVER say "Wrong." Say "Let's try it together," break the word into sounds, blend them, then ask the child to repeat it successfully.</a:t>
-            </a:r>
-          </a:p>
         </p:txBody>
       </p:sp>
       <p:sp>
@@ -1377,47 +1057,7 @@
         <p:txBody>
           <a:bodyPr/>
           <a:lstStyle/>
-          <a:p>
-            <a:r>
-              <a:t>⏱ TIME: 38–45 min     |     READING MODE: WE DO, then YOU DO if comfortable</a:t>
-            </a:r>
-          </a:p>
           <a:p/>
-          <a:p>
-            <a:r>
-              <a:t>WHAT TO SAY: My turn first, then we read together, then your turn. I see a cat. Now with me: I see a cat.</a:t>
-            </a:r>
-          </a:p>
-          <a:p/>
-          <a:p>
-            <a:r>
-              <a:t>QUESTION TO ASK: Which word says CAT? Can you read it with me?</a:t>
-            </a:r>
-          </a:p>
-          <a:p/>
-          <a:p>
-            <a:r>
-              <a:t>EXPECTED RESPONSE: I see a cat.  •  The dog is big.</a:t>
-            </a:r>
-          </a:p>
-          <a:p/>
-          <a:p>
-            <a:r>
-              <a:t>IF THE CHILD STRUGGLES: Cover all but the first word, then reveal one word at a time as the child reads. Do not correct in the middle — wait until the end of the sentence.</a:t>
-            </a:r>
-          </a:p>
-          <a:p/>
-          <a:p>
-            <a:r>
-              <a:t>PRAISE: Nice reading! Take your time, there is no rush.</a:t>
-            </a:r>
-          </a:p>
-          <a:p/>
-          <a:p>
-            <a:r>
-              <a:t>NEVER say "Wrong." Say "Let's try it together," break the word into sounds, blend them, then ask the child to repeat it successfully.</a:t>
-            </a:r>
-          </a:p>
         </p:txBody>
       </p:sp>
       <p:sp>
@@ -1483,47 +1123,7 @@
         <p:txBody>
           <a:bodyPr/>
           <a:lstStyle/>
-          <a:p>
-            <a:r>
-              <a:t>⏱ TIME: 38–45 min     |     READING MODE: YOU DO with support ready</a:t>
-            </a:r>
-          </a:p>
           <a:p/>
-          <a:p>
-            <a:r>
-              <a:t>WHAT TO SAY: These two are yours. If a word feels tricky, we will sound it out together — that is what good readers do.</a:t>
-            </a:r>
-          </a:p>
-          <a:p/>
-          <a:p>
-            <a:r>
-              <a:t>QUESTION TO ASK: Can you read this one all by yourself?</a:t>
-            </a:r>
-          </a:p>
-          <a:p/>
-          <a:p>
-            <a:r>
-              <a:t>EXPECTED RESPONSE: I can run.  •  I see the sun.</a:t>
-            </a:r>
-          </a:p>
-          <a:p/>
-          <a:p>
-            <a:r>
-              <a:t>IF THE CHILD STRUGGLES: Break the tricky word into sounds, blend them, then say the word and ask the child to repeat it successfully. Always finish on a success.</a:t>
-            </a:r>
-          </a:p>
-          <a:p/>
-          <a:p>
-            <a:r>
-              <a:t>PRAISE: You read that all by yourself! I am so proud of you.</a:t>
-            </a:r>
-          </a:p>
-          <a:p/>
-          <a:p>
-            <a:r>
-              <a:t>NEVER say "Wrong." Say "Let's try it together," break the word into sounds, blend them, then ask the child to repeat it successfully.</a:t>
-            </a:r>
-          </a:p>
         </p:txBody>
       </p:sp>
       <p:sp>
@@ -1589,47 +1189,7 @@
         <p:txBody>
           <a:bodyPr/>
           <a:lstStyle/>
-          <a:p>
-            <a:r>
-              <a:t>⏱ TIME: 45–50 min     |     READING MODE: Reading plus picture comprehension</a:t>
-            </a:r>
-          </a:p>
           <a:p/>
-          <a:p>
-            <a:r>
-              <a:t>WHAT TO SAY: Here is a park. Let's see what is in it — a sun, a tree, a dog, a ball, and a cat. Now read this sentence with me: The dog is big.</a:t>
-            </a:r>
-          </a:p>
-          <a:p/>
-          <a:p>
-            <a:r>
-              <a:t>QUESTION TO ASK: Can you find the dog in the picture? Which sentence tells us about the dog?</a:t>
-            </a:r>
-          </a:p>
-          <a:p/>
-          <a:p>
-            <a:r>
-              <a:t>EXPECTED RESPONSE: Sentence 1 is about the dog. Sentence 2 is about the sun. Sentence 3 is about the cat.</a:t>
-            </a:r>
-          </a:p>
-          <a:p/>
-          <a:p>
-            <a:r>
-              <a:t>IF THE CHILD STRUGGLES: Read the sentence aloud yourself, then ask the child to point to the matching picture. Pointing is easier than reading and still shows understanding.</a:t>
-            </a:r>
-          </a:p>
-          <a:p/>
-          <a:p>
-            <a:r>
-              <a:t>PRAISE: You found it! You are reading AND thinking.</a:t>
-            </a:r>
-          </a:p>
-          <a:p/>
-          <a:p>
-            <a:r>
-              <a:t>NEVER say "Wrong." Say "Let's try it together," break the word into sounds, blend them, then ask the child to repeat it successfully.</a:t>
-            </a:r>
-          </a:p>
         </p:txBody>
       </p:sp>
       <p:sp>
@@ -1695,47 +1255,7 @@
         <p:txBody>
           <a:bodyPr/>
           <a:lstStyle/>
-          <a:p>
-            <a:r>
-              <a:t>⏱ TIME: 0–5 min     |     READING MODE: No reading required</a:t>
-            </a:r>
-          </a:p>
           <a:p/>
-          <a:p>
-            <a:r>
-              <a:t>WHAT TO SAY: Here are our four friends. This is Bunny, this is Bear, this is Puppy, and this is Cat. They will help us read today. Let's say hi to each one.</a:t>
-            </a:r>
-          </a:p>
-          <a:p/>
-          <a:p>
-            <a:r>
-              <a:t>QUESTION TO ASK: Which friend is your favorite? Can you make a bunny sound?</a:t>
-            </a:r>
-          </a:p>
-          <a:p/>
-          <a:p>
-            <a:r>
-              <a:t>EXPECTED RESPONSE: The child names a favorite animal and makes a sound or a hop motion.</a:t>
-            </a:r>
-          </a:p>
-          <a:p/>
-          <a:p>
-            <a:r>
-              <a:t>IF THE CHILD STRUGGLES: Point to one and say 'This is Bunny. Can you say Bunny?' Keep it playful.</a:t>
-            </a:r>
-          </a:p>
-          <a:p/>
-          <a:p>
-            <a:r>
-              <a:t>PRAISE: Great! Bunny likes you already.</a:t>
-            </a:r>
-          </a:p>
-          <a:p/>
-          <a:p>
-            <a:r>
-              <a:t>NEVER say "Wrong." Say "Let's try it together," break the word into sounds, blend them, then ask the child to repeat it successfully.</a:t>
-            </a:r>
-          </a:p>
         </p:txBody>
       </p:sp>
       <p:sp>
@@ -1801,47 +1321,7 @@
         <p:txBody>
           <a:bodyPr/>
           <a:lstStyle/>
-          <a:p>
-            <a:r>
-              <a:t>⏱ TIME: 50–56 min     |     READING MODE: WE DO, teacher models each word</a:t>
-            </a:r>
-          </a:p>
           <a:p/>
-          <a:p>
-            <a:r>
-              <a:t>WHAT TO SAY: Before we read Bunny's story, let's meet the words we will see. This one is BUNNY. Bunny can hop. Your turn: BUNNY.</a:t>
-            </a:r>
-          </a:p>
-          <a:p/>
-          <a:p>
-            <a:r>
-              <a:t>QUESTION TO ASK: What is this word? Can you read the little sentence with me?</a:t>
-            </a:r>
-          </a:p>
-          <a:p/>
-          <a:p>
-            <a:r>
-              <a:t>EXPECTED RESPONSE: The child repeats each word and reads at least four of them.</a:t>
-            </a:r>
-          </a:p>
-          <a:p/>
-          <a:p>
-            <a:r>
-              <a:t>IF THE CHILD STRUGGLES: Cover the word and show only the picture, then reveal the word and blend it together. Skip 'happy' and 'play' if time is short.</a:t>
-            </a:r>
-          </a:p>
-          <a:p/>
-          <a:p>
-            <a:r>
-              <a:t>PRAISE: You already know so many of these — the story will be easy for you!</a:t>
-            </a:r>
-          </a:p>
-          <a:p/>
-          <a:p>
-            <a:r>
-              <a:t>NEVER say "Wrong." Say "Let's try it together," break the word into sounds, blend them, then ask the child to repeat it successfully.</a:t>
-            </a:r>
-          </a:p>
         </p:txBody>
       </p:sp>
       <p:sp>
@@ -1907,47 +1387,7 @@
         <p:txBody>
           <a:bodyPr/>
           <a:lstStyle/>
-          <a:p>
-            <a:r>
-              <a:t>⏱ TIME: 50–56 min     |     READING MODE: I DO → WE DO → child picks one line</a:t>
-            </a:r>
-          </a:p>
           <a:p/>
-          <a:p>
-            <a:r>
-              <a:t>WHAT TO SAY: Story time! Bunny is going somewhere fun today. Listen while I read, then we read together, then you pick just one line to read by yourself.</a:t>
-            </a:r>
-          </a:p>
-          <a:p/>
-          <a:p>
-            <a:r>
-              <a:t>QUESTION TO ASK: Where is Bunny going? What does Bunny see?</a:t>
-            </a:r>
-          </a:p>
-          <a:p/>
-          <a:p>
-            <a:r>
-              <a:t>EXPECTED RESPONSE: Bunny goes to the park. The sun is big. Bunny sees a dog. The dog is big.</a:t>
-            </a:r>
-          </a:p>
-          <a:p/>
-          <a:p>
-            <a:r>
-              <a:t>IF THE CHILD STRUGGLES: Offer the shortest line: 'The sun is big.' Letting the child choose the line removes almost all the worry.</a:t>
-            </a:r>
-          </a:p>
-          <a:p/>
-          <a:p>
-            <a:r>
-              <a:t>PRAISE: You picked a line and read it. That is being a real reader!</a:t>
-            </a:r>
-          </a:p>
-          <a:p/>
-          <a:p>
-            <a:r>
-              <a:t>NEVER say "Wrong." Say "Let's try it together," break the word into sounds, blend them, then ask the child to repeat it successfully.</a:t>
-            </a:r>
-          </a:p>
         </p:txBody>
       </p:sp>
       <p:sp>
@@ -2013,47 +1453,7 @@
         <p:txBody>
           <a:bodyPr/>
           <a:lstStyle/>
-          <a:p>
-            <a:r>
-              <a:t>⏱ TIME: 50–56 min     |     READING MODE: I DO → WE DO → child reads a talking line</a:t>
-            </a:r>
-          </a:p>
           <a:p/>
-          <a:p>
-            <a:r>
-              <a:t>WHAT TO SAY: Look what the dog has — a red ball! Let's find out what Bunny says.</a:t>
-            </a:r>
-          </a:p>
-          <a:p/>
-          <a:p>
-            <a:r>
-              <a:t>QUESTION TO ASK: What does the dog have? What do you think Bunny will say?</a:t>
-            </a:r>
-          </a:p>
-          <a:p/>
-          <a:p>
-            <a:r>
-              <a:t>EXPECTED RESPONSE: The dog has a red ball. Bunny runs to the dog. "Can I play?" says Bunny. "Yes!" says the dog.</a:t>
-            </a:r>
-          </a:p>
-          <a:p/>
-          <a:p>
-            <a:r>
-              <a:t>IF THE CHILD STRUGGLES: Explain that the marks around the words mean somebody is talking. Read the talking lines in a fun voice and let the child copy you.</a:t>
-            </a:r>
-          </a:p>
-          <a:p/>
-          <a:p>
-            <a:r>
-              <a:t>PRAISE: I loved your Bunny voice! That was excellent reading.</a:t>
-            </a:r>
-          </a:p>
-          <a:p/>
-          <a:p>
-            <a:r>
-              <a:t>NEVER say "Wrong." Say "Let's try it together," break the word into sounds, blend them, then ask the child to repeat it successfully.</a:t>
-            </a:r>
-          </a:p>
         </p:txBody>
       </p:sp>
       <p:sp>
@@ -2119,47 +1519,7 @@
         <p:txBody>
           <a:bodyPr/>
           <a:lstStyle/>
-          <a:p>
-            <a:r>
-              <a:t>⏱ TIME: 50–56 min     |     READING MODE: I DO → WE DO → child reads one or two lines</a:t>
-            </a:r>
-          </a:p>
           <a:p/>
-          <a:p>
-            <a:r>
-              <a:t>WHAT TO SAY: And here is the happy ending. Bunny and the dog play together all day.</a:t>
-            </a:r>
-          </a:p>
-          <a:p/>
-          <a:p>
-            <a:r>
-              <a:t>QUESTION TO ASK: How does Bunny feel? Can you tell me the story in your own words?</a:t>
-            </a:r>
-          </a:p>
-          <a:p/>
-          <a:p>
-            <a:r>
-              <a:t>EXPECTED RESPONSE: They play with the ball. Bunny can run. Bunny is happy. It is a fun day!</a:t>
-            </a:r>
-          </a:p>
-          <a:p/>
-          <a:p>
-            <a:r>
-              <a:t>IF THE CHILD STRUGGLES: Retell the story together using the three story slides as picture prompts, one sentence per slide.</a:t>
-            </a:r>
-          </a:p>
-          <a:p/>
-          <a:p>
-            <a:r>
-              <a:t>PRAISE: You read a whole story today! Not just words — a whole story.</a:t>
-            </a:r>
-          </a:p>
-          <a:p/>
-          <a:p>
-            <a:r>
-              <a:t>NEVER say "Wrong." Say "Let's try it together," break the word into sounds, blend them, then ask the child to repeat it successfully.</a:t>
-            </a:r>
-          </a:p>
         </p:txBody>
       </p:sp>
       <p:sp>
@@ -2225,47 +1585,7 @@
         <p:txBody>
           <a:bodyPr/>
           <a:lstStyle/>
-          <a:p>
-            <a:r>
-              <a:t>⏱ TIME: 56–58 min     |     READING MODE: Listening and pointing, no reading needed</a:t>
-            </a:r>
-          </a:p>
           <a:p/>
-          <a:p>
-            <a:r>
-              <a:t>WHAT TO SAY: Let's think about Bunny's story. Where does Bunny go? Point to your answer.</a:t>
-            </a:r>
-          </a:p>
-          <a:p/>
-          <a:p>
-            <a:r>
-              <a:t>QUESTION TO ASK: Where does Bunny go? What does the dog have? How does Bunny feel?</a:t>
-            </a:r>
-          </a:p>
-          <a:p/>
-          <a:p>
-            <a:r>
-              <a:t>EXPECTED RESPONSE: 1. Park   2. A ball   3. Happy</a:t>
-            </a:r>
-          </a:p>
-          <a:p/>
-          <a:p>
-            <a:r>
-              <a:t>IF THE CHILD STRUGGLES: Go back to the story slide and read the line that holds the answer, then ask again. Offer two choices instead of three if needed.</a:t>
-            </a:r>
-          </a:p>
-          <a:p/>
-          <a:p>
-            <a:r>
-              <a:t>PRAISE: That is exactly right! You remembered the story so well.</a:t>
-            </a:r>
-          </a:p>
-          <a:p/>
-          <a:p>
-            <a:r>
-              <a:t>NEVER say "Wrong." Say "Let's try it together," break the word into sounds, blend them, then ask the child to repeat it successfully.</a:t>
-            </a:r>
-          </a:p>
         </p:txBody>
       </p:sp>
       <p:sp>
@@ -2331,47 +1651,7 @@
         <p:txBody>
           <a:bodyPr/>
           <a:lstStyle/>
-          <a:p>
-            <a:r>
-              <a:t>⏱ TIME: 58–60 min     |     READING MODE: YOU DO — celebrate, never correct harshly</a:t>
-            </a:r>
-          </a:p>
           <a:p/>
-          <a:p>
-            <a:r>
-              <a:t>WHAT TO SAY: Last challenge, Reading Superhero! Read as many as you can. There is no pass or fail here — every word you read is a win.</a:t>
-            </a:r>
-          </a:p>
-          <a:p/>
-          <a:p>
-            <a:r>
-              <a:t>QUESTION TO ASK: Can you read this word? Now can you read the sentence?</a:t>
-            </a:r>
-          </a:p>
-          <a:p/>
-          <a:p>
-            <a:r>
-              <a:t>EXPECTED RESPONSE: CAT, SUN, DOG, and 'I see a dog.'</a:t>
-            </a:r>
-          </a:p>
-          <a:p/>
-          <a:p>
-            <a:r>
-              <a:t>IF THE CHILD STRUGGLES: Sound out the first word together to build momentum, then step back and let the child lead. Count successes aloud: 'That's two! That's three!'</a:t>
-            </a:r>
-          </a:p>
-          <a:p/>
-          <a:p>
-            <a:r>
-              <a:t>PRAISE: You read three words! Look how much you learned in one class.</a:t>
-            </a:r>
-          </a:p>
-          <a:p/>
-          <a:p>
-            <a:r>
-              <a:t>NEVER say "Wrong." Say "Let's try it together," break the word into sounds, blend them, then ask the child to repeat it successfully.</a:t>
-            </a:r>
-          </a:p>
         </p:txBody>
       </p:sp>
       <p:sp>
@@ -2437,47 +1717,7 @@
         <p:txBody>
           <a:bodyPr/>
           <a:lstStyle/>
-          <a:p>
-            <a:r>
-              <a:t>⏱ TIME: 58–60 min     |     READING MODE: Speaking only</a:t>
-            </a:r>
-          </a:p>
           <a:p/>
-          <a:p>
-            <a:r>
-              <a:t>WHAT TO SAY: Look at everything you can do now! Letter sounds, blending, words, sentences, a whole story, and answering questions. That is a lot for one class.</a:t>
-            </a:r>
-          </a:p>
-          <a:p/>
-          <a:p>
-            <a:r>
-              <a:t>QUESTION TO ASK: What was your favorite game? What word do you remember best?</a:t>
-            </a:r>
-          </a:p>
-          <a:p/>
-          <a:p>
-            <a:r>
-              <a:t>EXPECTED RESPONSE: The child names a favorite game and recalls at least one or two words.</a:t>
-            </a:r>
-          </a:p>
-          <a:p/>
-          <a:p>
-            <a:r>
-              <a:t>IF THE CHILD STRUGGLES: Prompt with the first sound: 'We read about a b... bunny!'</a:t>
-            </a:r>
-          </a:p>
-          <a:p/>
-          <a:p>
-            <a:r>
-              <a:t>PRAISE: You should be proud of yourself today. I certainly am!</a:t>
-            </a:r>
-          </a:p>
-          <a:p/>
-          <a:p>
-            <a:r>
-              <a:t>NEVER say "Wrong." Say "Let's try it together," break the word into sounds, blend them, then ask the child to repeat it successfully.</a:t>
-            </a:r>
-          </a:p>
         </p:txBody>
       </p:sp>
       <p:sp>
@@ -2543,47 +1783,7 @@
         <p:txBody>
           <a:bodyPr/>
           <a:lstStyle/>
-          <a:p>
-            <a:r>
-              <a:t>⏱ TIME: 58–60 min     |     READING MODE: Celebration only</a:t>
-            </a:r>
-          </a:p>
           <a:p/>
-          <a:p>
-            <a:r>
-              <a:t>WHAT TO SAY: This badge is for you. You are officially a Reading Superstar. You read sounds, words, sentences and a whole story today, and Bunny says thank you!</a:t>
-            </a:r>
-          </a:p>
-          <a:p/>
-          <a:p>
-            <a:r>
-              <a:t>QUESTION TO ASK: Do you want to show this badge to your family?</a:t>
-            </a:r>
-          </a:p>
-          <a:p/>
-          <a:p>
-            <a:r>
-              <a:t>EXPECTED RESPONSE: A smile, a thank you, or a question about the next class.</a:t>
-            </a:r>
-          </a:p>
-          <a:p/>
-          <a:p>
-            <a:r>
-              <a:t>IF THE CHILD STRUGGLES: If the child seems shy about praise, name one concrete fact: 'You read three words all by yourself.'</a:t>
-            </a:r>
-          </a:p>
-          <a:p/>
-          <a:p>
-            <a:r>
-              <a:t>PRAISE: I am so proud of you. See you next time, Reading Explorer!</a:t>
-            </a:r>
-          </a:p>
-          <a:p/>
-          <a:p>
-            <a:r>
-              <a:t>NEVER say "Wrong." Say "Let's try it together," break the word into sounds, blend them, then ask the child to repeat it successfully.</a:t>
-            </a:r>
-          </a:p>
         </p:txBody>
       </p:sp>
       <p:sp>
@@ -2649,47 +1849,7 @@
         <p:txBody>
           <a:bodyPr/>
           <a:lstStyle/>
-          <a:p>
-            <a:r>
-              <a:t>⏱ TIME: After class     |     READING MODE: Teacher record</a:t>
-            </a:r>
-          </a:p>
           <a:p/>
-          <a:p>
-            <a:r>
-              <a:t>WHAT TO SAY: TEACHER SLIDE — do not display to the child.</a:t>
-            </a:r>
-          </a:p>
-          <a:p/>
-          <a:p>
-            <a:r>
-              <a:t>QUESTION TO ASK: Fill this in within five minutes of finishing, while the details are fresh.</a:t>
-            </a:r>
-          </a:p>
-          <a:p/>
-          <a:p>
-            <a:r>
-              <a:t>EXPECTED RESPONSE: A Grade 1 child who struggles with reading will often sit at Emerging for sentence reading and Developing for comprehension, because listening comprehension usually runs ahead of decoding.</a:t>
-            </a:r>
-          </a:p>
-          <a:p/>
-          <a:p>
-            <a:r>
-              <a:t>IF THE CHILD STRUGGLES: Record how many words and sentences were read independently in the Reading Superhero Challenge — that single number is the clearest way to show progress to the parent next lesson.</a:t>
-            </a:r>
-          </a:p>
-          <a:p/>
-          <a:p>
-            <a:r>
-              <a:t>PRAISE: Frame parent feedback as strengths first, then one growth area, then the plan.</a:t>
-            </a:r>
-          </a:p>
-          <a:p/>
-          <a:p>
-            <a:r>
-              <a:t>NEVER say "Wrong." Say "Let's try it together," break the word into sounds, blend them, then ask the child to repeat it successfully.</a:t>
-            </a:r>
-          </a:p>
         </p:txBody>
       </p:sp>
       <p:sp>
@@ -2755,47 +1915,7 @@
         <p:txBody>
           <a:bodyPr/>
           <a:lstStyle/>
-          <a:p>
-            <a:r>
-              <a:t>⏱ TIME: Reference     |     READING MODE: Teacher only</a:t>
-            </a:r>
-          </a:p>
           <a:p/>
-          <a:p>
-            <a:r>
-              <a:t>WHAT TO SAY: TEACHER SLIDE — answers for the phonics, blending, CVC and sight word games.</a:t>
-            </a:r>
-          </a:p>
-          <a:p/>
-          <a:p>
-            <a:r>
-              <a:t>QUESTION TO ASK: Hide this slide in PowerPoint (right-click the thumbnail, then Hide Slide) before presenting, or keep it open on a second screen.</a:t>
-            </a:r>
-          </a:p>
-          <a:p/>
-          <a:p>
-            <a:r>
-              <a:t>EXPECTED RESPONSE: See the slide content for all answers.</a:t>
-            </a:r>
-          </a:p>
-          <a:p/>
-          <a:p>
-            <a:r>
-              <a:t>IF THE CHILD STRUGGLES: Use the Sound Detective and Catch the Sight Word results to choose which sounds and words to review at the start of the next lesson.</a:t>
-            </a:r>
-          </a:p>
-          <a:p/>
-          <a:p>
-            <a:r>
-              <a:t>PRAISE: Reference only.</a:t>
-            </a:r>
-          </a:p>
-          <a:p/>
-          <a:p>
-            <a:r>
-              <a:t>NEVER say "Wrong." Say "Let's try it together," break the word into sounds, blend them, then ask the child to repeat it successfully.</a:t>
-            </a:r>
-          </a:p>
         </p:txBody>
       </p:sp>
       <p:sp>
@@ -2861,47 +1981,7 @@
         <p:txBody>
           <a:bodyPr/>
           <a:lstStyle/>
-          <a:p>
-            <a:r>
-              <a:t>⏱ TIME: 0–5 min     |     READING MODE: Speaking only, no reading</a:t>
-            </a:r>
-          </a:p>
           <a:p/>
-          <a:p>
-            <a:r>
-              <a:t>WHAT TO SAY: Let's warm up our talking voices. Point to this one — what is it? Yes, a dog! Now tell me about you.</a:t>
-            </a:r>
-          </a:p>
-          <a:p/>
-          <a:p>
-            <a:r>
-              <a:t>QUESTION TO ASK: What do you see in the picture? What is your name? Do you like stories?</a:t>
-            </a:r>
-          </a:p>
-          <a:p/>
-          <a:p>
-            <a:r>
-              <a:t>EXPECTED RESPONSE: Dog, cat, sun, apple. Then short spoken answers to each question.</a:t>
-            </a:r>
-          </a:p>
-          <a:p/>
-          <a:p>
-            <a:r>
-              <a:t>IF THE CHILD STRUGGLES: Name the picture yourself first, then ask the child to repeat it back to you.</a:t>
-            </a:r>
-          </a:p>
-          <a:p/>
-          <a:p>
-            <a:r>
-              <a:t>PRAISE: You know all of these! Great talking.</a:t>
-            </a:r>
-          </a:p>
-          <a:p/>
-          <a:p>
-            <a:r>
-              <a:t>NEVER say "Wrong." Say "Let's try it together," break the word into sounds, blend them, then ask the child to repeat it successfully.</a:t>
-            </a:r>
-          </a:p>
         </p:txBody>
       </p:sp>
       <p:sp>
@@ -2967,47 +2047,7 @@
         <p:txBody>
           <a:bodyPr/>
           <a:lstStyle/>
-          <a:p>
-            <a:r>
-              <a:t>⏱ TIME: Reference     |     READING MODE: Teacher only</a:t>
-            </a:r>
-          </a:p>
           <a:p/>
-          <a:p>
-            <a:r>
-              <a:t>WHAT TO SAY: TEACHER SLIDE — answers for the sentence work, Read and Find, the story and the comprehension questions.</a:t>
-            </a:r>
-          </a:p>
-          <a:p/>
-          <a:p>
-            <a:r>
-              <a:t>QUESTION TO ASK: Hide this slide before presenting.</a:t>
-            </a:r>
-          </a:p>
-          <a:p/>
-          <a:p>
-            <a:r>
-              <a:t>EXPECTED RESPONSE: See the slide content for all answers.</a:t>
-            </a:r>
-          </a:p>
-          <a:p/>
-          <a:p>
-            <a:r>
-              <a:t>IF THE CHILD STRUGGLES: For a child who finishes early, ask them to point to the line in the story that proves each comprehension answer.</a:t>
-            </a:r>
-          </a:p>
-          <a:p/>
-          <a:p>
-            <a:r>
-              <a:t>PRAISE: Reference only.</a:t>
-            </a:r>
-          </a:p>
-          <a:p/>
-          <a:p>
-            <a:r>
-              <a:t>NEVER say "Wrong." Say "Let's try it together," break the word into sounds, blend them, then ask the child to repeat it successfully.</a:t>
-            </a:r>
-          </a:p>
         </p:txBody>
       </p:sp>
       <p:sp>
@@ -3073,47 +2113,7 @@
         <p:txBody>
           <a:bodyPr/>
           <a:lstStyle/>
-          <a:p>
-            <a:r>
-              <a:t>⏱ TIME: 5–12 min     |     READING MODE: Listen and repeat, then identify</a:t>
-            </a:r>
-          </a:p>
           <a:p/>
-          <a:p>
-            <a:r>
-              <a:t>WHAT TO SAY: Let's wake up our sounds. The letter m says /m/... like map. Your turn: /m/. Now s says /s/... like sun.</a:t>
-            </a:r>
-          </a:p>
-          <a:p/>
-          <a:p>
-            <a:r>
-              <a:t>QUESTION TO ASK: What sound does this letter make?</a:t>
-            </a:r>
-          </a:p>
-          <a:p/>
-          <a:p>
-            <a:r>
-              <a:t>EXPECTED RESPONSE: The child repeats each sound, then names sounds alone when you point.</a:t>
-            </a:r>
-          </a:p>
-          <a:p/>
-          <a:p>
-            <a:r>
-              <a:t>IF THE CHILD STRUGGLES: Say the sound with the picture and stretch it out: 'mmmmap — /m/ /m/ /m/.' Use only four letters if attention drops.</a:t>
-            </a:r>
-          </a:p>
-          <a:p/>
-          <a:p>
-            <a:r>
-              <a:t>PRAISE: Your sounds are getting stronger already!</a:t>
-            </a:r>
-          </a:p>
-          <a:p/>
-          <a:p>
-            <a:r>
-              <a:t>NEVER say "Wrong." Say "Let's try it together," break the word into sounds, blend them, then ask the child to repeat it successfully.</a:t>
-            </a:r>
-          </a:p>
         </p:txBody>
       </p:sp>
       <p:sp>
@@ -3179,47 +2179,7 @@
         <p:txBody>
           <a:bodyPr/>
           <a:lstStyle/>
-          <a:p>
-            <a:r>
-              <a:t>⏱ TIME: 5–12 min     |     READING MODE: Listening, child points to answer</a:t>
-            </a:r>
-          </a:p>
           <a:p/>
-          <a:p>
-            <a:r>
-              <a:t>WHAT TO SAY: Detective time! Look at the picture. Cccc-at. What sound do you hear at the very beginning of cat? Is it A, B, or C?</a:t>
-            </a:r>
-          </a:p>
-          <a:p/>
-          <a:p>
-            <a:r>
-              <a:t>QUESTION TO ASK: What sound does this word start with?</a:t>
-            </a:r>
-          </a:p>
-          <a:p/>
-          <a:p>
-            <a:r>
-              <a:t>EXPECTED RESPONSE: 1. /k/   2. /m/   3. /s/</a:t>
-            </a:r>
-          </a:p>
-          <a:p/>
-          <a:p>
-            <a:r>
-              <a:t>IF THE CHILD STRUGGLES: Stretch the first sound three times: 'ccccc-at.' Then read the three choices aloud and let the child point.</a:t>
-            </a:r>
-          </a:p>
-          <a:p/>
-          <a:p>
-            <a:r>
-              <a:t>PRAISE: Great job, Reading Detective!</a:t>
-            </a:r>
-          </a:p>
-          <a:p/>
-          <a:p>
-            <a:r>
-              <a:t>NEVER say "Wrong." Say "Let's try it together," break the word into sounds, blend them, then ask the child to repeat it successfully.</a:t>
-            </a:r>
-          </a:p>
         </p:txBody>
       </p:sp>
       <p:sp>
@@ -3285,47 +2245,7 @@
         <p:txBody>
           <a:bodyPr/>
           <a:lstStyle/>
-          <a:p>
-            <a:r>
-              <a:t>⏱ TIME: 5–12 min     |     READING MODE: Listening, child points to answer</a:t>
-            </a:r>
-          </a:p>
           <a:p/>
-          <a:p>
-            <a:r>
-              <a:t>WHAT TO SAY: Three more mysteries! Tttt-ree. Which sound is at the beginning?</a:t>
-            </a:r>
-          </a:p>
-          <a:p/>
-          <a:p>
-            <a:r>
-              <a:t>QUESTION TO ASK: What sound do you hear first?</a:t>
-            </a:r>
-          </a:p>
-          <a:p/>
-          <a:p>
-            <a:r>
-              <a:t>EXPECTED RESPONSE: 4. /t/   5. /p/   6. /d/</a:t>
-            </a:r>
-          </a:p>
-          <a:p/>
-          <a:p>
-            <a:r>
-              <a:t>IF THE CHILD STRUGGLES: Cover one wrong choice with your finger so there are only two options left.</a:t>
-            </a:r>
-          </a:p>
-          <a:p/>
-          <a:p>
-            <a:r>
-              <a:t>PRAISE: You found it! Nothing gets past you.</a:t>
-            </a:r>
-          </a:p>
-          <a:p/>
-          <a:p>
-            <a:r>
-              <a:t>NEVER say "Wrong." Say "Let's try it together," break the word into sounds, blend them, then ask the child to repeat it successfully.</a:t>
-            </a:r>
-          </a:p>
         </p:txBody>
       </p:sp>
       <p:sp>
@@ -3391,47 +2311,7 @@
         <p:txBody>
           <a:bodyPr/>
           <a:lstStyle/>
-          <a:p>
-            <a:r>
-              <a:t>⏱ TIME: 12–20 min     |     READING MODE: I DO → WE DO → YOU DO</a:t>
-            </a:r>
-          </a:p>
           <a:p/>
-          <a:p>
-            <a:r>
-              <a:t>WHAT TO SAY: Watch this. When sounds hold hands, they make a word. /k/ ... /a/ ... /t/. Now faster: /k/-/a/-/t/... CAT!</a:t>
-            </a:r>
-          </a:p>
-          <a:p/>
-          <a:p>
-            <a:r>
-              <a:t>QUESTION TO ASK: Can you blend them with me? What word did we make?</a:t>
-            </a:r>
-          </a:p>
-          <a:p/>
-          <a:p>
-            <a:r>
-              <a:t>EXPECTED RESPONSE: The child says CAT, first with you and then alone.</a:t>
-            </a:r>
-          </a:p>
-          <a:p/>
-          <a:p>
-            <a:r>
-              <a:t>IF THE CHILD STRUGGLES: Blend just the first two sounds: /k/ /a/ = 'ca'. Then add /t/. Sweep your finger under the letters so the child sees the left-to-right movement.</a:t>
-            </a:r>
-          </a:p>
-          <a:p/>
-          <a:p>
-            <a:r>
-              <a:t>PRAISE: You made the sounds turn into a word. That is reading!</a:t>
-            </a:r>
-          </a:p>
-          <a:p/>
-          <a:p>
-            <a:r>
-              <a:t>NEVER say "Wrong." Say "Let's try it together," break the word into sounds, blend them, then ask the child to repeat it successfully.</a:t>
-            </a:r>
-          </a:p>
         </p:txBody>
       </p:sp>
       <p:sp>
@@ -3497,47 +2377,7 @@
         <p:txBody>
           <a:bodyPr/>
           <a:lstStyle/>
-          <a:p>
-            <a:r>
-              <a:t>⏱ TIME: 12–20 min     |     READING MODE: WE DO first, then YOU DO</a:t>
-            </a:r>
-          </a:p>
           <a:p/>
-          <a:p>
-            <a:r>
-              <a:t>WHAT TO SAY: Let's build words! Say each sound with me: /m/ /a/ /t/. Now blend them fast... MAT!</a:t>
-            </a:r>
-          </a:p>
-          <a:p/>
-          <a:p>
-            <a:r>
-              <a:t>QUESTION TO ASK: What sound is first? What word did we build?</a:t>
-            </a:r>
-          </a:p>
-          <a:p/>
-          <a:p>
-            <a:r>
-              <a:t>EXPECTED RESPONSE: MAT  •  SUN  •  PIG  •  DOG</a:t>
-            </a:r>
-          </a:p>
-          <a:p/>
-          <a:p>
-            <a:r>
-              <a:t>IF THE CHILD STRUGGLES: Cover the last letter with your hand, blend the first two, then reveal the last sound and blend all three.</a:t>
-            </a:r>
-          </a:p>
-          <a:p/>
-          <a:p>
-            <a:r>
-              <a:t>PRAISE: You didn't give up — and you built it!</a:t>
-            </a:r>
-          </a:p>
-          <a:p/>
-          <a:p>
-            <a:r>
-              <a:t>NEVER say "Wrong." Say "Let's try it together," break the word into sounds, blend them, then ask the child to repeat it successfully.</a:t>
-            </a:r>
-          </a:p>
         </p:txBody>
       </p:sp>
       <p:sp>
@@ -3603,47 +2443,7 @@
         <p:txBody>
           <a:bodyPr/>
           <a:lstStyle/>
-          <a:p>
-            <a:r>
-              <a:t>⏱ TIME: 20–28 min     |     READING MODE: WE DO, then child tries one family alone</a:t>
-            </a:r>
-          </a:p>
           <a:p/>
-          <a:p>
-            <a:r>
-              <a:t>WHAT TO SAY: Look at this family. Cat, bat, mat, sat — they all end the same way. Only the first sound changes. Listen: /k/-at, /b/-at, /m/-at.</a:t>
-            </a:r>
-          </a:p>
-          <a:p/>
-          <a:p>
-            <a:r>
-              <a:t>QUESTION TO ASK: Can you read the next one in the family?</a:t>
-            </a:r>
-          </a:p>
-          <a:p/>
-          <a:p>
-            <a:r>
-              <a:t>EXPECTED RESPONSE: cat bat mat sat  •  dog log  •  sun run  •  pig big  •  hen pen</a:t>
-            </a:r>
-          </a:p>
-          <a:p/>
-          <a:p>
-            <a:r>
-              <a:t>IF THE CHILD STRUGGLES: Read the first word of the family yourself, then cover the first letter of the next word and reveal it slowly.</a:t>
-            </a:r>
-          </a:p>
-          <a:p/>
-          <a:p>
-            <a:r>
-              <a:t>PRAISE: Nice reading! You spotted the pattern.</a:t>
-            </a:r>
-          </a:p>
-          <a:p/>
-          <a:p>
-            <a:r>
-              <a:t>NEVER say "Wrong." Say "Let's try it together," break the word into sounds, blend them, then ask the child to repeat it successfully.</a:t>
-            </a:r>
-          </a:p>
         </p:txBody>
       </p:sp>
       <p:sp>

</xml_diff>

<commit_message>
Fully remove notes pages from the Grade 1 and Grade 2 reading decks.
Co-authored-by: Cursor <cursoragent@cursor.com>
</commit_message>
<xml_diff>
--- a/Grade1_Bunny_Reading_Adventure_60min.pptx
+++ b/Grade1_Bunny_Reading_Adventure_60min.pptx
@@ -484,1986 +484,6 @@
     </a:lvl9pPr>
   </p:notesStyle>
 </p:notesMaster>
-</file>
-
-<file path=ppt/notesSlides/notesSlide1.xml><?xml version="1.0" encoding="utf-8"?>
-<p:notes xmlns:a="http://schemas.openxmlformats.org/drawingml/2006/main" xmlns:p="http://schemas.openxmlformats.org/presentationml/2006/main" xmlns:r="http://schemas.openxmlformats.org/officeDocument/2006/relationships">
-  <p:cSld>
-    <p:spTree>
-      <p:nvGrpSpPr>
-        <p:cNvPr id="1" name=""/>
-        <p:cNvGrpSpPr/>
-        <p:nvPr/>
-      </p:nvGrpSpPr>
-      <p:grpSpPr>
-        <a:xfrm>
-          <a:off x="0" y="0"/>
-          <a:ext cx="0" cy="0"/>
-          <a:chOff x="0" y="0"/>
-          <a:chExt cx="0" cy="0"/>
-        </a:xfrm>
-      </p:grpSpPr>
-      <p:sp>
-        <p:nvSpPr>
-          <p:cNvPr id="2" name="Slide Image Placeholder 1"/>
-          <p:cNvSpPr>
-            <a:spLocks noGrp="1"/>
-          </p:cNvSpPr>
-          <p:nvPr>
-            <p:ph type="sldImg" idx="2"/>
-          </p:nvPr>
-        </p:nvSpPr>
-        <p:spPr/>
-      </p:sp>
-      <p:sp>
-        <p:nvSpPr>
-          <p:cNvPr id="3" name="Notes Placeholder 2"/>
-          <p:cNvSpPr>
-            <a:spLocks noGrp="1"/>
-          </p:cNvSpPr>
-          <p:nvPr>
-            <p:ph type="body" idx="3" sz="quarter"/>
-          </p:nvPr>
-        </p:nvSpPr>
-        <p:spPr/>
-        <p:txBody>
-          <a:bodyPr/>
-          <a:lstStyle/>
-          <a:p/>
-        </p:txBody>
-      </p:sp>
-      <p:sp>
-        <p:nvSpPr>
-          <p:cNvPr id="4" name="Slide Number Placeholder 3"/>
-          <p:cNvSpPr>
-            <a:spLocks noGrp="1"/>
-          </p:cNvSpPr>
-          <p:nvPr>
-            <p:ph type="sldNum" idx="5" sz="quarter"/>
-          </p:nvPr>
-        </p:nvSpPr>
-        <p:spPr/>
-      </p:sp>
-    </p:spTree>
-  </p:cSld>
-  <p:clrMapOvr>
-    <a:masterClrMapping/>
-  </p:clrMapOvr>
-</p:notes>
-</file>
-
-<file path=ppt/notesSlides/notesSlide10.xml><?xml version="1.0" encoding="utf-8"?>
-<p:notes xmlns:a="http://schemas.openxmlformats.org/drawingml/2006/main" xmlns:p="http://schemas.openxmlformats.org/presentationml/2006/main" xmlns:r="http://schemas.openxmlformats.org/officeDocument/2006/relationships">
-  <p:cSld>
-    <p:spTree>
-      <p:nvGrpSpPr>
-        <p:cNvPr id="1" name=""/>
-        <p:cNvGrpSpPr/>
-        <p:nvPr/>
-      </p:nvGrpSpPr>
-      <p:grpSpPr>
-        <a:xfrm>
-          <a:off x="0" y="0"/>
-          <a:ext cx="0" cy="0"/>
-          <a:chOff x="0" y="0"/>
-          <a:chExt cx="0" cy="0"/>
-        </a:xfrm>
-      </p:grpSpPr>
-      <p:sp>
-        <p:nvSpPr>
-          <p:cNvPr id="2" name="Slide Image Placeholder 1"/>
-          <p:cNvSpPr>
-            <a:spLocks noGrp="1"/>
-          </p:cNvSpPr>
-          <p:nvPr>
-            <p:ph type="sldImg" idx="2"/>
-          </p:nvPr>
-        </p:nvSpPr>
-        <p:spPr/>
-      </p:sp>
-      <p:sp>
-        <p:nvSpPr>
-          <p:cNvPr id="3" name="Notes Placeholder 2"/>
-          <p:cNvSpPr>
-            <a:spLocks noGrp="1"/>
-          </p:cNvSpPr>
-          <p:nvPr>
-            <p:ph type="body" idx="3" sz="quarter"/>
-          </p:nvPr>
-        </p:nvSpPr>
-        <p:spPr/>
-        <p:txBody>
-          <a:bodyPr/>
-          <a:lstStyle/>
-          <a:p/>
-        </p:txBody>
-      </p:sp>
-      <p:sp>
-        <p:nvSpPr>
-          <p:cNvPr id="4" name="Slide Number Placeholder 3"/>
-          <p:cNvSpPr>
-            <a:spLocks noGrp="1"/>
-          </p:cNvSpPr>
-          <p:nvPr>
-            <p:ph type="sldNum" idx="5" sz="quarter"/>
-          </p:nvPr>
-        </p:nvSpPr>
-        <p:spPr/>
-      </p:sp>
-    </p:spTree>
-  </p:cSld>
-  <p:clrMapOvr>
-    <a:masterClrMapping/>
-  </p:clrMapOvr>
-</p:notes>
-</file>
-
-<file path=ppt/notesSlides/notesSlide11.xml><?xml version="1.0" encoding="utf-8"?>
-<p:notes xmlns:a="http://schemas.openxmlformats.org/drawingml/2006/main" xmlns:p="http://schemas.openxmlformats.org/presentationml/2006/main" xmlns:r="http://schemas.openxmlformats.org/officeDocument/2006/relationships">
-  <p:cSld>
-    <p:spTree>
-      <p:nvGrpSpPr>
-        <p:cNvPr id="1" name=""/>
-        <p:cNvGrpSpPr/>
-        <p:nvPr/>
-      </p:nvGrpSpPr>
-      <p:grpSpPr>
-        <a:xfrm>
-          <a:off x="0" y="0"/>
-          <a:ext cx="0" cy="0"/>
-          <a:chOff x="0" y="0"/>
-          <a:chExt cx="0" cy="0"/>
-        </a:xfrm>
-      </p:grpSpPr>
-      <p:sp>
-        <p:nvSpPr>
-          <p:cNvPr id="2" name="Slide Image Placeholder 1"/>
-          <p:cNvSpPr>
-            <a:spLocks noGrp="1"/>
-          </p:cNvSpPr>
-          <p:nvPr>
-            <p:ph type="sldImg" idx="2"/>
-          </p:nvPr>
-        </p:nvSpPr>
-        <p:spPr/>
-      </p:sp>
-      <p:sp>
-        <p:nvSpPr>
-          <p:cNvPr id="3" name="Notes Placeholder 2"/>
-          <p:cNvSpPr>
-            <a:spLocks noGrp="1"/>
-          </p:cNvSpPr>
-          <p:nvPr>
-            <p:ph type="body" idx="3" sz="quarter"/>
-          </p:nvPr>
-        </p:nvSpPr>
-        <p:spPr/>
-        <p:txBody>
-          <a:bodyPr/>
-          <a:lstStyle/>
-          <a:p/>
-        </p:txBody>
-      </p:sp>
-      <p:sp>
-        <p:nvSpPr>
-          <p:cNvPr id="4" name="Slide Number Placeholder 3"/>
-          <p:cNvSpPr>
-            <a:spLocks noGrp="1"/>
-          </p:cNvSpPr>
-          <p:nvPr>
-            <p:ph type="sldNum" idx="5" sz="quarter"/>
-          </p:nvPr>
-        </p:nvSpPr>
-        <p:spPr/>
-      </p:sp>
-    </p:spTree>
-  </p:cSld>
-  <p:clrMapOvr>
-    <a:masterClrMapping/>
-  </p:clrMapOvr>
-</p:notes>
-</file>
-
-<file path=ppt/notesSlides/notesSlide12.xml><?xml version="1.0" encoding="utf-8"?>
-<p:notes xmlns:a="http://schemas.openxmlformats.org/drawingml/2006/main" xmlns:p="http://schemas.openxmlformats.org/presentationml/2006/main" xmlns:r="http://schemas.openxmlformats.org/officeDocument/2006/relationships">
-  <p:cSld>
-    <p:spTree>
-      <p:nvGrpSpPr>
-        <p:cNvPr id="1" name=""/>
-        <p:cNvGrpSpPr/>
-        <p:nvPr/>
-      </p:nvGrpSpPr>
-      <p:grpSpPr>
-        <a:xfrm>
-          <a:off x="0" y="0"/>
-          <a:ext cx="0" cy="0"/>
-          <a:chOff x="0" y="0"/>
-          <a:chExt cx="0" cy="0"/>
-        </a:xfrm>
-      </p:grpSpPr>
-      <p:sp>
-        <p:nvSpPr>
-          <p:cNvPr id="2" name="Slide Image Placeholder 1"/>
-          <p:cNvSpPr>
-            <a:spLocks noGrp="1"/>
-          </p:cNvSpPr>
-          <p:nvPr>
-            <p:ph type="sldImg" idx="2"/>
-          </p:nvPr>
-        </p:nvSpPr>
-        <p:spPr/>
-      </p:sp>
-      <p:sp>
-        <p:nvSpPr>
-          <p:cNvPr id="3" name="Notes Placeholder 2"/>
-          <p:cNvSpPr>
-            <a:spLocks noGrp="1"/>
-          </p:cNvSpPr>
-          <p:nvPr>
-            <p:ph type="body" idx="3" sz="quarter"/>
-          </p:nvPr>
-        </p:nvSpPr>
-        <p:spPr/>
-        <p:txBody>
-          <a:bodyPr/>
-          <a:lstStyle/>
-          <a:p/>
-        </p:txBody>
-      </p:sp>
-      <p:sp>
-        <p:nvSpPr>
-          <p:cNvPr id="4" name="Slide Number Placeholder 3"/>
-          <p:cNvSpPr>
-            <a:spLocks noGrp="1"/>
-          </p:cNvSpPr>
-          <p:nvPr>
-            <p:ph type="sldNum" idx="5" sz="quarter"/>
-          </p:nvPr>
-        </p:nvSpPr>
-        <p:spPr/>
-      </p:sp>
-    </p:spTree>
-  </p:cSld>
-  <p:clrMapOvr>
-    <a:masterClrMapping/>
-  </p:clrMapOvr>
-</p:notes>
-</file>
-
-<file path=ppt/notesSlides/notesSlide13.xml><?xml version="1.0" encoding="utf-8"?>
-<p:notes xmlns:a="http://schemas.openxmlformats.org/drawingml/2006/main" xmlns:p="http://schemas.openxmlformats.org/presentationml/2006/main" xmlns:r="http://schemas.openxmlformats.org/officeDocument/2006/relationships">
-  <p:cSld>
-    <p:spTree>
-      <p:nvGrpSpPr>
-        <p:cNvPr id="1" name=""/>
-        <p:cNvGrpSpPr/>
-        <p:nvPr/>
-      </p:nvGrpSpPr>
-      <p:grpSpPr>
-        <a:xfrm>
-          <a:off x="0" y="0"/>
-          <a:ext cx="0" cy="0"/>
-          <a:chOff x="0" y="0"/>
-          <a:chExt cx="0" cy="0"/>
-        </a:xfrm>
-      </p:grpSpPr>
-      <p:sp>
-        <p:nvSpPr>
-          <p:cNvPr id="2" name="Slide Image Placeholder 1"/>
-          <p:cNvSpPr>
-            <a:spLocks noGrp="1"/>
-          </p:cNvSpPr>
-          <p:nvPr>
-            <p:ph type="sldImg" idx="2"/>
-          </p:nvPr>
-        </p:nvSpPr>
-        <p:spPr/>
-      </p:sp>
-      <p:sp>
-        <p:nvSpPr>
-          <p:cNvPr id="3" name="Notes Placeholder 2"/>
-          <p:cNvSpPr>
-            <a:spLocks noGrp="1"/>
-          </p:cNvSpPr>
-          <p:nvPr>
-            <p:ph type="body" idx="3" sz="quarter"/>
-          </p:nvPr>
-        </p:nvSpPr>
-        <p:spPr/>
-        <p:txBody>
-          <a:bodyPr/>
-          <a:lstStyle/>
-          <a:p/>
-        </p:txBody>
-      </p:sp>
-      <p:sp>
-        <p:nvSpPr>
-          <p:cNvPr id="4" name="Slide Number Placeholder 3"/>
-          <p:cNvSpPr>
-            <a:spLocks noGrp="1"/>
-          </p:cNvSpPr>
-          <p:nvPr>
-            <p:ph type="sldNum" idx="5" sz="quarter"/>
-          </p:nvPr>
-        </p:nvSpPr>
-        <p:spPr/>
-      </p:sp>
-    </p:spTree>
-  </p:cSld>
-  <p:clrMapOvr>
-    <a:masterClrMapping/>
-  </p:clrMapOvr>
-</p:notes>
-</file>
-
-<file path=ppt/notesSlides/notesSlide14.xml><?xml version="1.0" encoding="utf-8"?>
-<p:notes xmlns:a="http://schemas.openxmlformats.org/drawingml/2006/main" xmlns:p="http://schemas.openxmlformats.org/presentationml/2006/main" xmlns:r="http://schemas.openxmlformats.org/officeDocument/2006/relationships">
-  <p:cSld>
-    <p:spTree>
-      <p:nvGrpSpPr>
-        <p:cNvPr id="1" name=""/>
-        <p:cNvGrpSpPr/>
-        <p:nvPr/>
-      </p:nvGrpSpPr>
-      <p:grpSpPr>
-        <a:xfrm>
-          <a:off x="0" y="0"/>
-          <a:ext cx="0" cy="0"/>
-          <a:chOff x="0" y="0"/>
-          <a:chExt cx="0" cy="0"/>
-        </a:xfrm>
-      </p:grpSpPr>
-      <p:sp>
-        <p:nvSpPr>
-          <p:cNvPr id="2" name="Slide Image Placeholder 1"/>
-          <p:cNvSpPr>
-            <a:spLocks noGrp="1"/>
-          </p:cNvSpPr>
-          <p:nvPr>
-            <p:ph type="sldImg" idx="2"/>
-          </p:nvPr>
-        </p:nvSpPr>
-        <p:spPr/>
-      </p:sp>
-      <p:sp>
-        <p:nvSpPr>
-          <p:cNvPr id="3" name="Notes Placeholder 2"/>
-          <p:cNvSpPr>
-            <a:spLocks noGrp="1"/>
-          </p:cNvSpPr>
-          <p:nvPr>
-            <p:ph type="body" idx="3" sz="quarter"/>
-          </p:nvPr>
-        </p:nvSpPr>
-        <p:spPr/>
-        <p:txBody>
-          <a:bodyPr/>
-          <a:lstStyle/>
-          <a:p/>
-        </p:txBody>
-      </p:sp>
-      <p:sp>
-        <p:nvSpPr>
-          <p:cNvPr id="4" name="Slide Number Placeholder 3"/>
-          <p:cNvSpPr>
-            <a:spLocks noGrp="1"/>
-          </p:cNvSpPr>
-          <p:nvPr>
-            <p:ph type="sldNum" idx="5" sz="quarter"/>
-          </p:nvPr>
-        </p:nvSpPr>
-        <p:spPr/>
-      </p:sp>
-    </p:spTree>
-  </p:cSld>
-  <p:clrMapOvr>
-    <a:masterClrMapping/>
-  </p:clrMapOvr>
-</p:notes>
-</file>
-
-<file path=ppt/notesSlides/notesSlide15.xml><?xml version="1.0" encoding="utf-8"?>
-<p:notes xmlns:a="http://schemas.openxmlformats.org/drawingml/2006/main" xmlns:p="http://schemas.openxmlformats.org/presentationml/2006/main" xmlns:r="http://schemas.openxmlformats.org/officeDocument/2006/relationships">
-  <p:cSld>
-    <p:spTree>
-      <p:nvGrpSpPr>
-        <p:cNvPr id="1" name=""/>
-        <p:cNvGrpSpPr/>
-        <p:nvPr/>
-      </p:nvGrpSpPr>
-      <p:grpSpPr>
-        <a:xfrm>
-          <a:off x="0" y="0"/>
-          <a:ext cx="0" cy="0"/>
-          <a:chOff x="0" y="0"/>
-          <a:chExt cx="0" cy="0"/>
-        </a:xfrm>
-      </p:grpSpPr>
-      <p:sp>
-        <p:nvSpPr>
-          <p:cNvPr id="2" name="Slide Image Placeholder 1"/>
-          <p:cNvSpPr>
-            <a:spLocks noGrp="1"/>
-          </p:cNvSpPr>
-          <p:nvPr>
-            <p:ph type="sldImg" idx="2"/>
-          </p:nvPr>
-        </p:nvSpPr>
-        <p:spPr/>
-      </p:sp>
-      <p:sp>
-        <p:nvSpPr>
-          <p:cNvPr id="3" name="Notes Placeholder 2"/>
-          <p:cNvSpPr>
-            <a:spLocks noGrp="1"/>
-          </p:cNvSpPr>
-          <p:nvPr>
-            <p:ph type="body" idx="3" sz="quarter"/>
-          </p:nvPr>
-        </p:nvSpPr>
-        <p:spPr/>
-        <p:txBody>
-          <a:bodyPr/>
-          <a:lstStyle/>
-          <a:p/>
-        </p:txBody>
-      </p:sp>
-      <p:sp>
-        <p:nvSpPr>
-          <p:cNvPr id="4" name="Slide Number Placeholder 3"/>
-          <p:cNvSpPr>
-            <a:spLocks noGrp="1"/>
-          </p:cNvSpPr>
-          <p:nvPr>
-            <p:ph type="sldNum" idx="5" sz="quarter"/>
-          </p:nvPr>
-        </p:nvSpPr>
-        <p:spPr/>
-      </p:sp>
-    </p:spTree>
-  </p:cSld>
-  <p:clrMapOvr>
-    <a:masterClrMapping/>
-  </p:clrMapOvr>
-</p:notes>
-</file>
-
-<file path=ppt/notesSlides/notesSlide16.xml><?xml version="1.0" encoding="utf-8"?>
-<p:notes xmlns:a="http://schemas.openxmlformats.org/drawingml/2006/main" xmlns:p="http://schemas.openxmlformats.org/presentationml/2006/main" xmlns:r="http://schemas.openxmlformats.org/officeDocument/2006/relationships">
-  <p:cSld>
-    <p:spTree>
-      <p:nvGrpSpPr>
-        <p:cNvPr id="1" name=""/>
-        <p:cNvGrpSpPr/>
-        <p:nvPr/>
-      </p:nvGrpSpPr>
-      <p:grpSpPr>
-        <a:xfrm>
-          <a:off x="0" y="0"/>
-          <a:ext cx="0" cy="0"/>
-          <a:chOff x="0" y="0"/>
-          <a:chExt cx="0" cy="0"/>
-        </a:xfrm>
-      </p:grpSpPr>
-      <p:sp>
-        <p:nvSpPr>
-          <p:cNvPr id="2" name="Slide Image Placeholder 1"/>
-          <p:cNvSpPr>
-            <a:spLocks noGrp="1"/>
-          </p:cNvSpPr>
-          <p:nvPr>
-            <p:ph type="sldImg" idx="2"/>
-          </p:nvPr>
-        </p:nvSpPr>
-        <p:spPr/>
-      </p:sp>
-      <p:sp>
-        <p:nvSpPr>
-          <p:cNvPr id="3" name="Notes Placeholder 2"/>
-          <p:cNvSpPr>
-            <a:spLocks noGrp="1"/>
-          </p:cNvSpPr>
-          <p:nvPr>
-            <p:ph type="body" idx="3" sz="quarter"/>
-          </p:nvPr>
-        </p:nvSpPr>
-        <p:spPr/>
-        <p:txBody>
-          <a:bodyPr/>
-          <a:lstStyle/>
-          <a:p/>
-        </p:txBody>
-      </p:sp>
-      <p:sp>
-        <p:nvSpPr>
-          <p:cNvPr id="4" name="Slide Number Placeholder 3"/>
-          <p:cNvSpPr>
-            <a:spLocks noGrp="1"/>
-          </p:cNvSpPr>
-          <p:nvPr>
-            <p:ph type="sldNum" idx="5" sz="quarter"/>
-          </p:nvPr>
-        </p:nvSpPr>
-        <p:spPr/>
-      </p:sp>
-    </p:spTree>
-  </p:cSld>
-  <p:clrMapOvr>
-    <a:masterClrMapping/>
-  </p:clrMapOvr>
-</p:notes>
-</file>
-
-<file path=ppt/notesSlides/notesSlide17.xml><?xml version="1.0" encoding="utf-8"?>
-<p:notes xmlns:a="http://schemas.openxmlformats.org/drawingml/2006/main" xmlns:p="http://schemas.openxmlformats.org/presentationml/2006/main" xmlns:r="http://schemas.openxmlformats.org/officeDocument/2006/relationships">
-  <p:cSld>
-    <p:spTree>
-      <p:nvGrpSpPr>
-        <p:cNvPr id="1" name=""/>
-        <p:cNvGrpSpPr/>
-        <p:nvPr/>
-      </p:nvGrpSpPr>
-      <p:grpSpPr>
-        <a:xfrm>
-          <a:off x="0" y="0"/>
-          <a:ext cx="0" cy="0"/>
-          <a:chOff x="0" y="0"/>
-          <a:chExt cx="0" cy="0"/>
-        </a:xfrm>
-      </p:grpSpPr>
-      <p:sp>
-        <p:nvSpPr>
-          <p:cNvPr id="2" name="Slide Image Placeholder 1"/>
-          <p:cNvSpPr>
-            <a:spLocks noGrp="1"/>
-          </p:cNvSpPr>
-          <p:nvPr>
-            <p:ph type="sldImg" idx="2"/>
-          </p:nvPr>
-        </p:nvSpPr>
-        <p:spPr/>
-      </p:sp>
-      <p:sp>
-        <p:nvSpPr>
-          <p:cNvPr id="3" name="Notes Placeholder 2"/>
-          <p:cNvSpPr>
-            <a:spLocks noGrp="1"/>
-          </p:cNvSpPr>
-          <p:nvPr>
-            <p:ph type="body" idx="3" sz="quarter"/>
-          </p:nvPr>
-        </p:nvSpPr>
-        <p:spPr/>
-        <p:txBody>
-          <a:bodyPr/>
-          <a:lstStyle/>
-          <a:p/>
-        </p:txBody>
-      </p:sp>
-      <p:sp>
-        <p:nvSpPr>
-          <p:cNvPr id="4" name="Slide Number Placeholder 3"/>
-          <p:cNvSpPr>
-            <a:spLocks noGrp="1"/>
-          </p:cNvSpPr>
-          <p:nvPr>
-            <p:ph type="sldNum" idx="5" sz="quarter"/>
-          </p:nvPr>
-        </p:nvSpPr>
-        <p:spPr/>
-      </p:sp>
-    </p:spTree>
-  </p:cSld>
-  <p:clrMapOvr>
-    <a:masterClrMapping/>
-  </p:clrMapOvr>
-</p:notes>
-</file>
-
-<file path=ppt/notesSlides/notesSlide18.xml><?xml version="1.0" encoding="utf-8"?>
-<p:notes xmlns:a="http://schemas.openxmlformats.org/drawingml/2006/main" xmlns:p="http://schemas.openxmlformats.org/presentationml/2006/main" xmlns:r="http://schemas.openxmlformats.org/officeDocument/2006/relationships">
-  <p:cSld>
-    <p:spTree>
-      <p:nvGrpSpPr>
-        <p:cNvPr id="1" name=""/>
-        <p:cNvGrpSpPr/>
-        <p:nvPr/>
-      </p:nvGrpSpPr>
-      <p:grpSpPr>
-        <a:xfrm>
-          <a:off x="0" y="0"/>
-          <a:ext cx="0" cy="0"/>
-          <a:chOff x="0" y="0"/>
-          <a:chExt cx="0" cy="0"/>
-        </a:xfrm>
-      </p:grpSpPr>
-      <p:sp>
-        <p:nvSpPr>
-          <p:cNvPr id="2" name="Slide Image Placeholder 1"/>
-          <p:cNvSpPr>
-            <a:spLocks noGrp="1"/>
-          </p:cNvSpPr>
-          <p:nvPr>
-            <p:ph type="sldImg" idx="2"/>
-          </p:nvPr>
-        </p:nvSpPr>
-        <p:spPr/>
-      </p:sp>
-      <p:sp>
-        <p:nvSpPr>
-          <p:cNvPr id="3" name="Notes Placeholder 2"/>
-          <p:cNvSpPr>
-            <a:spLocks noGrp="1"/>
-          </p:cNvSpPr>
-          <p:nvPr>
-            <p:ph type="body" idx="3" sz="quarter"/>
-          </p:nvPr>
-        </p:nvSpPr>
-        <p:spPr/>
-        <p:txBody>
-          <a:bodyPr/>
-          <a:lstStyle/>
-          <a:p/>
-        </p:txBody>
-      </p:sp>
-      <p:sp>
-        <p:nvSpPr>
-          <p:cNvPr id="4" name="Slide Number Placeholder 3"/>
-          <p:cNvSpPr>
-            <a:spLocks noGrp="1"/>
-          </p:cNvSpPr>
-          <p:nvPr>
-            <p:ph type="sldNum" idx="5" sz="quarter"/>
-          </p:nvPr>
-        </p:nvSpPr>
-        <p:spPr/>
-      </p:sp>
-    </p:spTree>
-  </p:cSld>
-  <p:clrMapOvr>
-    <a:masterClrMapping/>
-  </p:clrMapOvr>
-</p:notes>
-</file>
-
-<file path=ppt/notesSlides/notesSlide19.xml><?xml version="1.0" encoding="utf-8"?>
-<p:notes xmlns:a="http://schemas.openxmlformats.org/drawingml/2006/main" xmlns:p="http://schemas.openxmlformats.org/presentationml/2006/main" xmlns:r="http://schemas.openxmlformats.org/officeDocument/2006/relationships">
-  <p:cSld>
-    <p:spTree>
-      <p:nvGrpSpPr>
-        <p:cNvPr id="1" name=""/>
-        <p:cNvGrpSpPr/>
-        <p:nvPr/>
-      </p:nvGrpSpPr>
-      <p:grpSpPr>
-        <a:xfrm>
-          <a:off x="0" y="0"/>
-          <a:ext cx="0" cy="0"/>
-          <a:chOff x="0" y="0"/>
-          <a:chExt cx="0" cy="0"/>
-        </a:xfrm>
-      </p:grpSpPr>
-      <p:sp>
-        <p:nvSpPr>
-          <p:cNvPr id="2" name="Slide Image Placeholder 1"/>
-          <p:cNvSpPr>
-            <a:spLocks noGrp="1"/>
-          </p:cNvSpPr>
-          <p:nvPr>
-            <p:ph type="sldImg" idx="2"/>
-          </p:nvPr>
-        </p:nvSpPr>
-        <p:spPr/>
-      </p:sp>
-      <p:sp>
-        <p:nvSpPr>
-          <p:cNvPr id="3" name="Notes Placeholder 2"/>
-          <p:cNvSpPr>
-            <a:spLocks noGrp="1"/>
-          </p:cNvSpPr>
-          <p:nvPr>
-            <p:ph type="body" idx="3" sz="quarter"/>
-          </p:nvPr>
-        </p:nvSpPr>
-        <p:spPr/>
-        <p:txBody>
-          <a:bodyPr/>
-          <a:lstStyle/>
-          <a:p/>
-        </p:txBody>
-      </p:sp>
-      <p:sp>
-        <p:nvSpPr>
-          <p:cNvPr id="4" name="Slide Number Placeholder 3"/>
-          <p:cNvSpPr>
-            <a:spLocks noGrp="1"/>
-          </p:cNvSpPr>
-          <p:nvPr>
-            <p:ph type="sldNum" idx="5" sz="quarter"/>
-          </p:nvPr>
-        </p:nvSpPr>
-        <p:spPr/>
-      </p:sp>
-    </p:spTree>
-  </p:cSld>
-  <p:clrMapOvr>
-    <a:masterClrMapping/>
-  </p:clrMapOvr>
-</p:notes>
-</file>
-
-<file path=ppt/notesSlides/notesSlide2.xml><?xml version="1.0" encoding="utf-8"?>
-<p:notes xmlns:a="http://schemas.openxmlformats.org/drawingml/2006/main" xmlns:p="http://schemas.openxmlformats.org/presentationml/2006/main" xmlns:r="http://schemas.openxmlformats.org/officeDocument/2006/relationships">
-  <p:cSld>
-    <p:spTree>
-      <p:nvGrpSpPr>
-        <p:cNvPr id="1" name=""/>
-        <p:cNvGrpSpPr/>
-        <p:nvPr/>
-      </p:nvGrpSpPr>
-      <p:grpSpPr>
-        <a:xfrm>
-          <a:off x="0" y="0"/>
-          <a:ext cx="0" cy="0"/>
-          <a:chOff x="0" y="0"/>
-          <a:chExt cx="0" cy="0"/>
-        </a:xfrm>
-      </p:grpSpPr>
-      <p:sp>
-        <p:nvSpPr>
-          <p:cNvPr id="2" name="Slide Image Placeholder 1"/>
-          <p:cNvSpPr>
-            <a:spLocks noGrp="1"/>
-          </p:cNvSpPr>
-          <p:nvPr>
-            <p:ph type="sldImg" idx="2"/>
-          </p:nvPr>
-        </p:nvSpPr>
-        <p:spPr/>
-      </p:sp>
-      <p:sp>
-        <p:nvSpPr>
-          <p:cNvPr id="3" name="Notes Placeholder 2"/>
-          <p:cNvSpPr>
-            <a:spLocks noGrp="1"/>
-          </p:cNvSpPr>
-          <p:nvPr>
-            <p:ph type="body" idx="3" sz="quarter"/>
-          </p:nvPr>
-        </p:nvSpPr>
-        <p:spPr/>
-        <p:txBody>
-          <a:bodyPr/>
-          <a:lstStyle/>
-          <a:p/>
-        </p:txBody>
-      </p:sp>
-      <p:sp>
-        <p:nvSpPr>
-          <p:cNvPr id="4" name="Slide Number Placeholder 3"/>
-          <p:cNvSpPr>
-            <a:spLocks noGrp="1"/>
-          </p:cNvSpPr>
-          <p:nvPr>
-            <p:ph type="sldNum" idx="5" sz="quarter"/>
-          </p:nvPr>
-        </p:nvSpPr>
-        <p:spPr/>
-      </p:sp>
-    </p:spTree>
-  </p:cSld>
-  <p:clrMapOvr>
-    <a:masterClrMapping/>
-  </p:clrMapOvr>
-</p:notes>
-</file>
-
-<file path=ppt/notesSlides/notesSlide20.xml><?xml version="1.0" encoding="utf-8"?>
-<p:notes xmlns:a="http://schemas.openxmlformats.org/drawingml/2006/main" xmlns:p="http://schemas.openxmlformats.org/presentationml/2006/main" xmlns:r="http://schemas.openxmlformats.org/officeDocument/2006/relationships">
-  <p:cSld>
-    <p:spTree>
-      <p:nvGrpSpPr>
-        <p:cNvPr id="1" name=""/>
-        <p:cNvGrpSpPr/>
-        <p:nvPr/>
-      </p:nvGrpSpPr>
-      <p:grpSpPr>
-        <a:xfrm>
-          <a:off x="0" y="0"/>
-          <a:ext cx="0" cy="0"/>
-          <a:chOff x="0" y="0"/>
-          <a:chExt cx="0" cy="0"/>
-        </a:xfrm>
-      </p:grpSpPr>
-      <p:sp>
-        <p:nvSpPr>
-          <p:cNvPr id="2" name="Slide Image Placeholder 1"/>
-          <p:cNvSpPr>
-            <a:spLocks noGrp="1"/>
-          </p:cNvSpPr>
-          <p:nvPr>
-            <p:ph type="sldImg" idx="2"/>
-          </p:nvPr>
-        </p:nvSpPr>
-        <p:spPr/>
-      </p:sp>
-      <p:sp>
-        <p:nvSpPr>
-          <p:cNvPr id="3" name="Notes Placeholder 2"/>
-          <p:cNvSpPr>
-            <a:spLocks noGrp="1"/>
-          </p:cNvSpPr>
-          <p:nvPr>
-            <p:ph type="body" idx="3" sz="quarter"/>
-          </p:nvPr>
-        </p:nvSpPr>
-        <p:spPr/>
-        <p:txBody>
-          <a:bodyPr/>
-          <a:lstStyle/>
-          <a:p/>
-        </p:txBody>
-      </p:sp>
-      <p:sp>
-        <p:nvSpPr>
-          <p:cNvPr id="4" name="Slide Number Placeholder 3"/>
-          <p:cNvSpPr>
-            <a:spLocks noGrp="1"/>
-          </p:cNvSpPr>
-          <p:nvPr>
-            <p:ph type="sldNum" idx="5" sz="quarter"/>
-          </p:nvPr>
-        </p:nvSpPr>
-        <p:spPr/>
-      </p:sp>
-    </p:spTree>
-  </p:cSld>
-  <p:clrMapOvr>
-    <a:masterClrMapping/>
-  </p:clrMapOvr>
-</p:notes>
-</file>
-
-<file path=ppt/notesSlides/notesSlide21.xml><?xml version="1.0" encoding="utf-8"?>
-<p:notes xmlns:a="http://schemas.openxmlformats.org/drawingml/2006/main" xmlns:p="http://schemas.openxmlformats.org/presentationml/2006/main" xmlns:r="http://schemas.openxmlformats.org/officeDocument/2006/relationships">
-  <p:cSld>
-    <p:spTree>
-      <p:nvGrpSpPr>
-        <p:cNvPr id="1" name=""/>
-        <p:cNvGrpSpPr/>
-        <p:nvPr/>
-      </p:nvGrpSpPr>
-      <p:grpSpPr>
-        <a:xfrm>
-          <a:off x="0" y="0"/>
-          <a:ext cx="0" cy="0"/>
-          <a:chOff x="0" y="0"/>
-          <a:chExt cx="0" cy="0"/>
-        </a:xfrm>
-      </p:grpSpPr>
-      <p:sp>
-        <p:nvSpPr>
-          <p:cNvPr id="2" name="Slide Image Placeholder 1"/>
-          <p:cNvSpPr>
-            <a:spLocks noGrp="1"/>
-          </p:cNvSpPr>
-          <p:nvPr>
-            <p:ph type="sldImg" idx="2"/>
-          </p:nvPr>
-        </p:nvSpPr>
-        <p:spPr/>
-      </p:sp>
-      <p:sp>
-        <p:nvSpPr>
-          <p:cNvPr id="3" name="Notes Placeholder 2"/>
-          <p:cNvSpPr>
-            <a:spLocks noGrp="1"/>
-          </p:cNvSpPr>
-          <p:nvPr>
-            <p:ph type="body" idx="3" sz="quarter"/>
-          </p:nvPr>
-        </p:nvSpPr>
-        <p:spPr/>
-        <p:txBody>
-          <a:bodyPr/>
-          <a:lstStyle/>
-          <a:p/>
-        </p:txBody>
-      </p:sp>
-      <p:sp>
-        <p:nvSpPr>
-          <p:cNvPr id="4" name="Slide Number Placeholder 3"/>
-          <p:cNvSpPr>
-            <a:spLocks noGrp="1"/>
-          </p:cNvSpPr>
-          <p:nvPr>
-            <p:ph type="sldNum" idx="5" sz="quarter"/>
-          </p:nvPr>
-        </p:nvSpPr>
-        <p:spPr/>
-      </p:sp>
-    </p:spTree>
-  </p:cSld>
-  <p:clrMapOvr>
-    <a:masterClrMapping/>
-  </p:clrMapOvr>
-</p:notes>
-</file>
-
-<file path=ppt/notesSlides/notesSlide22.xml><?xml version="1.0" encoding="utf-8"?>
-<p:notes xmlns:a="http://schemas.openxmlformats.org/drawingml/2006/main" xmlns:p="http://schemas.openxmlformats.org/presentationml/2006/main" xmlns:r="http://schemas.openxmlformats.org/officeDocument/2006/relationships">
-  <p:cSld>
-    <p:spTree>
-      <p:nvGrpSpPr>
-        <p:cNvPr id="1" name=""/>
-        <p:cNvGrpSpPr/>
-        <p:nvPr/>
-      </p:nvGrpSpPr>
-      <p:grpSpPr>
-        <a:xfrm>
-          <a:off x="0" y="0"/>
-          <a:ext cx="0" cy="0"/>
-          <a:chOff x="0" y="0"/>
-          <a:chExt cx="0" cy="0"/>
-        </a:xfrm>
-      </p:grpSpPr>
-      <p:sp>
-        <p:nvSpPr>
-          <p:cNvPr id="2" name="Slide Image Placeholder 1"/>
-          <p:cNvSpPr>
-            <a:spLocks noGrp="1"/>
-          </p:cNvSpPr>
-          <p:nvPr>
-            <p:ph type="sldImg" idx="2"/>
-          </p:nvPr>
-        </p:nvSpPr>
-        <p:spPr/>
-      </p:sp>
-      <p:sp>
-        <p:nvSpPr>
-          <p:cNvPr id="3" name="Notes Placeholder 2"/>
-          <p:cNvSpPr>
-            <a:spLocks noGrp="1"/>
-          </p:cNvSpPr>
-          <p:nvPr>
-            <p:ph type="body" idx="3" sz="quarter"/>
-          </p:nvPr>
-        </p:nvSpPr>
-        <p:spPr/>
-        <p:txBody>
-          <a:bodyPr/>
-          <a:lstStyle/>
-          <a:p/>
-        </p:txBody>
-      </p:sp>
-      <p:sp>
-        <p:nvSpPr>
-          <p:cNvPr id="4" name="Slide Number Placeholder 3"/>
-          <p:cNvSpPr>
-            <a:spLocks noGrp="1"/>
-          </p:cNvSpPr>
-          <p:nvPr>
-            <p:ph type="sldNum" idx="5" sz="quarter"/>
-          </p:nvPr>
-        </p:nvSpPr>
-        <p:spPr/>
-      </p:sp>
-    </p:spTree>
-  </p:cSld>
-  <p:clrMapOvr>
-    <a:masterClrMapping/>
-  </p:clrMapOvr>
-</p:notes>
-</file>
-
-<file path=ppt/notesSlides/notesSlide23.xml><?xml version="1.0" encoding="utf-8"?>
-<p:notes xmlns:a="http://schemas.openxmlformats.org/drawingml/2006/main" xmlns:p="http://schemas.openxmlformats.org/presentationml/2006/main" xmlns:r="http://schemas.openxmlformats.org/officeDocument/2006/relationships">
-  <p:cSld>
-    <p:spTree>
-      <p:nvGrpSpPr>
-        <p:cNvPr id="1" name=""/>
-        <p:cNvGrpSpPr/>
-        <p:nvPr/>
-      </p:nvGrpSpPr>
-      <p:grpSpPr>
-        <a:xfrm>
-          <a:off x="0" y="0"/>
-          <a:ext cx="0" cy="0"/>
-          <a:chOff x="0" y="0"/>
-          <a:chExt cx="0" cy="0"/>
-        </a:xfrm>
-      </p:grpSpPr>
-      <p:sp>
-        <p:nvSpPr>
-          <p:cNvPr id="2" name="Slide Image Placeholder 1"/>
-          <p:cNvSpPr>
-            <a:spLocks noGrp="1"/>
-          </p:cNvSpPr>
-          <p:nvPr>
-            <p:ph type="sldImg" idx="2"/>
-          </p:nvPr>
-        </p:nvSpPr>
-        <p:spPr/>
-      </p:sp>
-      <p:sp>
-        <p:nvSpPr>
-          <p:cNvPr id="3" name="Notes Placeholder 2"/>
-          <p:cNvSpPr>
-            <a:spLocks noGrp="1"/>
-          </p:cNvSpPr>
-          <p:nvPr>
-            <p:ph type="body" idx="3" sz="quarter"/>
-          </p:nvPr>
-        </p:nvSpPr>
-        <p:spPr/>
-        <p:txBody>
-          <a:bodyPr/>
-          <a:lstStyle/>
-          <a:p/>
-        </p:txBody>
-      </p:sp>
-      <p:sp>
-        <p:nvSpPr>
-          <p:cNvPr id="4" name="Slide Number Placeholder 3"/>
-          <p:cNvSpPr>
-            <a:spLocks noGrp="1"/>
-          </p:cNvSpPr>
-          <p:nvPr>
-            <p:ph type="sldNum" idx="5" sz="quarter"/>
-          </p:nvPr>
-        </p:nvSpPr>
-        <p:spPr/>
-      </p:sp>
-    </p:spTree>
-  </p:cSld>
-  <p:clrMapOvr>
-    <a:masterClrMapping/>
-  </p:clrMapOvr>
-</p:notes>
-</file>
-
-<file path=ppt/notesSlides/notesSlide24.xml><?xml version="1.0" encoding="utf-8"?>
-<p:notes xmlns:a="http://schemas.openxmlformats.org/drawingml/2006/main" xmlns:p="http://schemas.openxmlformats.org/presentationml/2006/main" xmlns:r="http://schemas.openxmlformats.org/officeDocument/2006/relationships">
-  <p:cSld>
-    <p:spTree>
-      <p:nvGrpSpPr>
-        <p:cNvPr id="1" name=""/>
-        <p:cNvGrpSpPr/>
-        <p:nvPr/>
-      </p:nvGrpSpPr>
-      <p:grpSpPr>
-        <a:xfrm>
-          <a:off x="0" y="0"/>
-          <a:ext cx="0" cy="0"/>
-          <a:chOff x="0" y="0"/>
-          <a:chExt cx="0" cy="0"/>
-        </a:xfrm>
-      </p:grpSpPr>
-      <p:sp>
-        <p:nvSpPr>
-          <p:cNvPr id="2" name="Slide Image Placeholder 1"/>
-          <p:cNvSpPr>
-            <a:spLocks noGrp="1"/>
-          </p:cNvSpPr>
-          <p:nvPr>
-            <p:ph type="sldImg" idx="2"/>
-          </p:nvPr>
-        </p:nvSpPr>
-        <p:spPr/>
-      </p:sp>
-      <p:sp>
-        <p:nvSpPr>
-          <p:cNvPr id="3" name="Notes Placeholder 2"/>
-          <p:cNvSpPr>
-            <a:spLocks noGrp="1"/>
-          </p:cNvSpPr>
-          <p:nvPr>
-            <p:ph type="body" idx="3" sz="quarter"/>
-          </p:nvPr>
-        </p:nvSpPr>
-        <p:spPr/>
-        <p:txBody>
-          <a:bodyPr/>
-          <a:lstStyle/>
-          <a:p/>
-        </p:txBody>
-      </p:sp>
-      <p:sp>
-        <p:nvSpPr>
-          <p:cNvPr id="4" name="Slide Number Placeholder 3"/>
-          <p:cNvSpPr>
-            <a:spLocks noGrp="1"/>
-          </p:cNvSpPr>
-          <p:nvPr>
-            <p:ph type="sldNum" idx="5" sz="quarter"/>
-          </p:nvPr>
-        </p:nvSpPr>
-        <p:spPr/>
-      </p:sp>
-    </p:spTree>
-  </p:cSld>
-  <p:clrMapOvr>
-    <a:masterClrMapping/>
-  </p:clrMapOvr>
-</p:notes>
-</file>
-
-<file path=ppt/notesSlides/notesSlide25.xml><?xml version="1.0" encoding="utf-8"?>
-<p:notes xmlns:a="http://schemas.openxmlformats.org/drawingml/2006/main" xmlns:p="http://schemas.openxmlformats.org/presentationml/2006/main" xmlns:r="http://schemas.openxmlformats.org/officeDocument/2006/relationships">
-  <p:cSld>
-    <p:spTree>
-      <p:nvGrpSpPr>
-        <p:cNvPr id="1" name=""/>
-        <p:cNvGrpSpPr/>
-        <p:nvPr/>
-      </p:nvGrpSpPr>
-      <p:grpSpPr>
-        <a:xfrm>
-          <a:off x="0" y="0"/>
-          <a:ext cx="0" cy="0"/>
-          <a:chOff x="0" y="0"/>
-          <a:chExt cx="0" cy="0"/>
-        </a:xfrm>
-      </p:grpSpPr>
-      <p:sp>
-        <p:nvSpPr>
-          <p:cNvPr id="2" name="Slide Image Placeholder 1"/>
-          <p:cNvSpPr>
-            <a:spLocks noGrp="1"/>
-          </p:cNvSpPr>
-          <p:nvPr>
-            <p:ph type="sldImg" idx="2"/>
-          </p:nvPr>
-        </p:nvSpPr>
-        <p:spPr/>
-      </p:sp>
-      <p:sp>
-        <p:nvSpPr>
-          <p:cNvPr id="3" name="Notes Placeholder 2"/>
-          <p:cNvSpPr>
-            <a:spLocks noGrp="1"/>
-          </p:cNvSpPr>
-          <p:nvPr>
-            <p:ph type="body" idx="3" sz="quarter"/>
-          </p:nvPr>
-        </p:nvSpPr>
-        <p:spPr/>
-        <p:txBody>
-          <a:bodyPr/>
-          <a:lstStyle/>
-          <a:p/>
-        </p:txBody>
-      </p:sp>
-      <p:sp>
-        <p:nvSpPr>
-          <p:cNvPr id="4" name="Slide Number Placeholder 3"/>
-          <p:cNvSpPr>
-            <a:spLocks noGrp="1"/>
-          </p:cNvSpPr>
-          <p:nvPr>
-            <p:ph type="sldNum" idx="5" sz="quarter"/>
-          </p:nvPr>
-        </p:nvSpPr>
-        <p:spPr/>
-      </p:sp>
-    </p:spTree>
-  </p:cSld>
-  <p:clrMapOvr>
-    <a:masterClrMapping/>
-  </p:clrMapOvr>
-</p:notes>
-</file>
-
-<file path=ppt/notesSlides/notesSlide26.xml><?xml version="1.0" encoding="utf-8"?>
-<p:notes xmlns:a="http://schemas.openxmlformats.org/drawingml/2006/main" xmlns:p="http://schemas.openxmlformats.org/presentationml/2006/main" xmlns:r="http://schemas.openxmlformats.org/officeDocument/2006/relationships">
-  <p:cSld>
-    <p:spTree>
-      <p:nvGrpSpPr>
-        <p:cNvPr id="1" name=""/>
-        <p:cNvGrpSpPr/>
-        <p:nvPr/>
-      </p:nvGrpSpPr>
-      <p:grpSpPr>
-        <a:xfrm>
-          <a:off x="0" y="0"/>
-          <a:ext cx="0" cy="0"/>
-          <a:chOff x="0" y="0"/>
-          <a:chExt cx="0" cy="0"/>
-        </a:xfrm>
-      </p:grpSpPr>
-      <p:sp>
-        <p:nvSpPr>
-          <p:cNvPr id="2" name="Slide Image Placeholder 1"/>
-          <p:cNvSpPr>
-            <a:spLocks noGrp="1"/>
-          </p:cNvSpPr>
-          <p:nvPr>
-            <p:ph type="sldImg" idx="2"/>
-          </p:nvPr>
-        </p:nvSpPr>
-        <p:spPr/>
-      </p:sp>
-      <p:sp>
-        <p:nvSpPr>
-          <p:cNvPr id="3" name="Notes Placeholder 2"/>
-          <p:cNvSpPr>
-            <a:spLocks noGrp="1"/>
-          </p:cNvSpPr>
-          <p:nvPr>
-            <p:ph type="body" idx="3" sz="quarter"/>
-          </p:nvPr>
-        </p:nvSpPr>
-        <p:spPr/>
-        <p:txBody>
-          <a:bodyPr/>
-          <a:lstStyle/>
-          <a:p/>
-        </p:txBody>
-      </p:sp>
-      <p:sp>
-        <p:nvSpPr>
-          <p:cNvPr id="4" name="Slide Number Placeholder 3"/>
-          <p:cNvSpPr>
-            <a:spLocks noGrp="1"/>
-          </p:cNvSpPr>
-          <p:nvPr>
-            <p:ph type="sldNum" idx="5" sz="quarter"/>
-          </p:nvPr>
-        </p:nvSpPr>
-        <p:spPr/>
-      </p:sp>
-    </p:spTree>
-  </p:cSld>
-  <p:clrMapOvr>
-    <a:masterClrMapping/>
-  </p:clrMapOvr>
-</p:notes>
-</file>
-
-<file path=ppt/notesSlides/notesSlide27.xml><?xml version="1.0" encoding="utf-8"?>
-<p:notes xmlns:a="http://schemas.openxmlformats.org/drawingml/2006/main" xmlns:p="http://schemas.openxmlformats.org/presentationml/2006/main" xmlns:r="http://schemas.openxmlformats.org/officeDocument/2006/relationships">
-  <p:cSld>
-    <p:spTree>
-      <p:nvGrpSpPr>
-        <p:cNvPr id="1" name=""/>
-        <p:cNvGrpSpPr/>
-        <p:nvPr/>
-      </p:nvGrpSpPr>
-      <p:grpSpPr>
-        <a:xfrm>
-          <a:off x="0" y="0"/>
-          <a:ext cx="0" cy="0"/>
-          <a:chOff x="0" y="0"/>
-          <a:chExt cx="0" cy="0"/>
-        </a:xfrm>
-      </p:grpSpPr>
-      <p:sp>
-        <p:nvSpPr>
-          <p:cNvPr id="2" name="Slide Image Placeholder 1"/>
-          <p:cNvSpPr>
-            <a:spLocks noGrp="1"/>
-          </p:cNvSpPr>
-          <p:nvPr>
-            <p:ph type="sldImg" idx="2"/>
-          </p:nvPr>
-        </p:nvSpPr>
-        <p:spPr/>
-      </p:sp>
-      <p:sp>
-        <p:nvSpPr>
-          <p:cNvPr id="3" name="Notes Placeholder 2"/>
-          <p:cNvSpPr>
-            <a:spLocks noGrp="1"/>
-          </p:cNvSpPr>
-          <p:nvPr>
-            <p:ph type="body" idx="3" sz="quarter"/>
-          </p:nvPr>
-        </p:nvSpPr>
-        <p:spPr/>
-        <p:txBody>
-          <a:bodyPr/>
-          <a:lstStyle/>
-          <a:p/>
-        </p:txBody>
-      </p:sp>
-      <p:sp>
-        <p:nvSpPr>
-          <p:cNvPr id="4" name="Slide Number Placeholder 3"/>
-          <p:cNvSpPr>
-            <a:spLocks noGrp="1"/>
-          </p:cNvSpPr>
-          <p:nvPr>
-            <p:ph type="sldNum" idx="5" sz="quarter"/>
-          </p:nvPr>
-        </p:nvSpPr>
-        <p:spPr/>
-      </p:sp>
-    </p:spTree>
-  </p:cSld>
-  <p:clrMapOvr>
-    <a:masterClrMapping/>
-  </p:clrMapOvr>
-</p:notes>
-</file>
-
-<file path=ppt/notesSlides/notesSlide28.xml><?xml version="1.0" encoding="utf-8"?>
-<p:notes xmlns:a="http://schemas.openxmlformats.org/drawingml/2006/main" xmlns:p="http://schemas.openxmlformats.org/presentationml/2006/main" xmlns:r="http://schemas.openxmlformats.org/officeDocument/2006/relationships">
-  <p:cSld>
-    <p:spTree>
-      <p:nvGrpSpPr>
-        <p:cNvPr id="1" name=""/>
-        <p:cNvGrpSpPr/>
-        <p:nvPr/>
-      </p:nvGrpSpPr>
-      <p:grpSpPr>
-        <a:xfrm>
-          <a:off x="0" y="0"/>
-          <a:ext cx="0" cy="0"/>
-          <a:chOff x="0" y="0"/>
-          <a:chExt cx="0" cy="0"/>
-        </a:xfrm>
-      </p:grpSpPr>
-      <p:sp>
-        <p:nvSpPr>
-          <p:cNvPr id="2" name="Slide Image Placeholder 1"/>
-          <p:cNvSpPr>
-            <a:spLocks noGrp="1"/>
-          </p:cNvSpPr>
-          <p:nvPr>
-            <p:ph type="sldImg" idx="2"/>
-          </p:nvPr>
-        </p:nvSpPr>
-        <p:spPr/>
-      </p:sp>
-      <p:sp>
-        <p:nvSpPr>
-          <p:cNvPr id="3" name="Notes Placeholder 2"/>
-          <p:cNvSpPr>
-            <a:spLocks noGrp="1"/>
-          </p:cNvSpPr>
-          <p:nvPr>
-            <p:ph type="body" idx="3" sz="quarter"/>
-          </p:nvPr>
-        </p:nvSpPr>
-        <p:spPr/>
-        <p:txBody>
-          <a:bodyPr/>
-          <a:lstStyle/>
-          <a:p/>
-        </p:txBody>
-      </p:sp>
-      <p:sp>
-        <p:nvSpPr>
-          <p:cNvPr id="4" name="Slide Number Placeholder 3"/>
-          <p:cNvSpPr>
-            <a:spLocks noGrp="1"/>
-          </p:cNvSpPr>
-          <p:nvPr>
-            <p:ph type="sldNum" idx="5" sz="quarter"/>
-          </p:nvPr>
-        </p:nvSpPr>
-        <p:spPr/>
-      </p:sp>
-    </p:spTree>
-  </p:cSld>
-  <p:clrMapOvr>
-    <a:masterClrMapping/>
-  </p:clrMapOvr>
-</p:notes>
-</file>
-
-<file path=ppt/notesSlides/notesSlide29.xml><?xml version="1.0" encoding="utf-8"?>
-<p:notes xmlns:a="http://schemas.openxmlformats.org/drawingml/2006/main" xmlns:p="http://schemas.openxmlformats.org/presentationml/2006/main" xmlns:r="http://schemas.openxmlformats.org/officeDocument/2006/relationships">
-  <p:cSld>
-    <p:spTree>
-      <p:nvGrpSpPr>
-        <p:cNvPr id="1" name=""/>
-        <p:cNvGrpSpPr/>
-        <p:nvPr/>
-      </p:nvGrpSpPr>
-      <p:grpSpPr>
-        <a:xfrm>
-          <a:off x="0" y="0"/>
-          <a:ext cx="0" cy="0"/>
-          <a:chOff x="0" y="0"/>
-          <a:chExt cx="0" cy="0"/>
-        </a:xfrm>
-      </p:grpSpPr>
-      <p:sp>
-        <p:nvSpPr>
-          <p:cNvPr id="2" name="Slide Image Placeholder 1"/>
-          <p:cNvSpPr>
-            <a:spLocks noGrp="1"/>
-          </p:cNvSpPr>
-          <p:nvPr>
-            <p:ph type="sldImg" idx="2"/>
-          </p:nvPr>
-        </p:nvSpPr>
-        <p:spPr/>
-      </p:sp>
-      <p:sp>
-        <p:nvSpPr>
-          <p:cNvPr id="3" name="Notes Placeholder 2"/>
-          <p:cNvSpPr>
-            <a:spLocks noGrp="1"/>
-          </p:cNvSpPr>
-          <p:nvPr>
-            <p:ph type="body" idx="3" sz="quarter"/>
-          </p:nvPr>
-        </p:nvSpPr>
-        <p:spPr/>
-        <p:txBody>
-          <a:bodyPr/>
-          <a:lstStyle/>
-          <a:p/>
-        </p:txBody>
-      </p:sp>
-      <p:sp>
-        <p:nvSpPr>
-          <p:cNvPr id="4" name="Slide Number Placeholder 3"/>
-          <p:cNvSpPr>
-            <a:spLocks noGrp="1"/>
-          </p:cNvSpPr>
-          <p:nvPr>
-            <p:ph type="sldNum" idx="5" sz="quarter"/>
-          </p:nvPr>
-        </p:nvSpPr>
-        <p:spPr/>
-      </p:sp>
-    </p:spTree>
-  </p:cSld>
-  <p:clrMapOvr>
-    <a:masterClrMapping/>
-  </p:clrMapOvr>
-</p:notes>
-</file>
-
-<file path=ppt/notesSlides/notesSlide3.xml><?xml version="1.0" encoding="utf-8"?>
-<p:notes xmlns:a="http://schemas.openxmlformats.org/drawingml/2006/main" xmlns:p="http://schemas.openxmlformats.org/presentationml/2006/main" xmlns:r="http://schemas.openxmlformats.org/officeDocument/2006/relationships">
-  <p:cSld>
-    <p:spTree>
-      <p:nvGrpSpPr>
-        <p:cNvPr id="1" name=""/>
-        <p:cNvGrpSpPr/>
-        <p:nvPr/>
-      </p:nvGrpSpPr>
-      <p:grpSpPr>
-        <a:xfrm>
-          <a:off x="0" y="0"/>
-          <a:ext cx="0" cy="0"/>
-          <a:chOff x="0" y="0"/>
-          <a:chExt cx="0" cy="0"/>
-        </a:xfrm>
-      </p:grpSpPr>
-      <p:sp>
-        <p:nvSpPr>
-          <p:cNvPr id="2" name="Slide Image Placeholder 1"/>
-          <p:cNvSpPr>
-            <a:spLocks noGrp="1"/>
-          </p:cNvSpPr>
-          <p:nvPr>
-            <p:ph type="sldImg" idx="2"/>
-          </p:nvPr>
-        </p:nvSpPr>
-        <p:spPr/>
-      </p:sp>
-      <p:sp>
-        <p:nvSpPr>
-          <p:cNvPr id="3" name="Notes Placeholder 2"/>
-          <p:cNvSpPr>
-            <a:spLocks noGrp="1"/>
-          </p:cNvSpPr>
-          <p:nvPr>
-            <p:ph type="body" idx="3" sz="quarter"/>
-          </p:nvPr>
-        </p:nvSpPr>
-        <p:spPr/>
-        <p:txBody>
-          <a:bodyPr/>
-          <a:lstStyle/>
-          <a:p/>
-        </p:txBody>
-      </p:sp>
-      <p:sp>
-        <p:nvSpPr>
-          <p:cNvPr id="4" name="Slide Number Placeholder 3"/>
-          <p:cNvSpPr>
-            <a:spLocks noGrp="1"/>
-          </p:cNvSpPr>
-          <p:nvPr>
-            <p:ph type="sldNum" idx="5" sz="quarter"/>
-          </p:nvPr>
-        </p:nvSpPr>
-        <p:spPr/>
-      </p:sp>
-    </p:spTree>
-  </p:cSld>
-  <p:clrMapOvr>
-    <a:masterClrMapping/>
-  </p:clrMapOvr>
-</p:notes>
-</file>
-
-<file path=ppt/notesSlides/notesSlide30.xml><?xml version="1.0" encoding="utf-8"?>
-<p:notes xmlns:a="http://schemas.openxmlformats.org/drawingml/2006/main" xmlns:p="http://schemas.openxmlformats.org/presentationml/2006/main" xmlns:r="http://schemas.openxmlformats.org/officeDocument/2006/relationships">
-  <p:cSld>
-    <p:spTree>
-      <p:nvGrpSpPr>
-        <p:cNvPr id="1" name=""/>
-        <p:cNvGrpSpPr/>
-        <p:nvPr/>
-      </p:nvGrpSpPr>
-      <p:grpSpPr>
-        <a:xfrm>
-          <a:off x="0" y="0"/>
-          <a:ext cx="0" cy="0"/>
-          <a:chOff x="0" y="0"/>
-          <a:chExt cx="0" cy="0"/>
-        </a:xfrm>
-      </p:grpSpPr>
-      <p:sp>
-        <p:nvSpPr>
-          <p:cNvPr id="2" name="Slide Image Placeholder 1"/>
-          <p:cNvSpPr>
-            <a:spLocks noGrp="1"/>
-          </p:cNvSpPr>
-          <p:nvPr>
-            <p:ph type="sldImg" idx="2"/>
-          </p:nvPr>
-        </p:nvSpPr>
-        <p:spPr/>
-      </p:sp>
-      <p:sp>
-        <p:nvSpPr>
-          <p:cNvPr id="3" name="Notes Placeholder 2"/>
-          <p:cNvSpPr>
-            <a:spLocks noGrp="1"/>
-          </p:cNvSpPr>
-          <p:nvPr>
-            <p:ph type="body" idx="3" sz="quarter"/>
-          </p:nvPr>
-        </p:nvSpPr>
-        <p:spPr/>
-        <p:txBody>
-          <a:bodyPr/>
-          <a:lstStyle/>
-          <a:p/>
-        </p:txBody>
-      </p:sp>
-      <p:sp>
-        <p:nvSpPr>
-          <p:cNvPr id="4" name="Slide Number Placeholder 3"/>
-          <p:cNvSpPr>
-            <a:spLocks noGrp="1"/>
-          </p:cNvSpPr>
-          <p:nvPr>
-            <p:ph type="sldNum" idx="5" sz="quarter"/>
-          </p:nvPr>
-        </p:nvSpPr>
-        <p:spPr/>
-      </p:sp>
-    </p:spTree>
-  </p:cSld>
-  <p:clrMapOvr>
-    <a:masterClrMapping/>
-  </p:clrMapOvr>
-</p:notes>
-</file>
-
-<file path=ppt/notesSlides/notesSlide4.xml><?xml version="1.0" encoding="utf-8"?>
-<p:notes xmlns:a="http://schemas.openxmlformats.org/drawingml/2006/main" xmlns:p="http://schemas.openxmlformats.org/presentationml/2006/main" xmlns:r="http://schemas.openxmlformats.org/officeDocument/2006/relationships">
-  <p:cSld>
-    <p:spTree>
-      <p:nvGrpSpPr>
-        <p:cNvPr id="1" name=""/>
-        <p:cNvGrpSpPr/>
-        <p:nvPr/>
-      </p:nvGrpSpPr>
-      <p:grpSpPr>
-        <a:xfrm>
-          <a:off x="0" y="0"/>
-          <a:ext cx="0" cy="0"/>
-          <a:chOff x="0" y="0"/>
-          <a:chExt cx="0" cy="0"/>
-        </a:xfrm>
-      </p:grpSpPr>
-      <p:sp>
-        <p:nvSpPr>
-          <p:cNvPr id="2" name="Slide Image Placeholder 1"/>
-          <p:cNvSpPr>
-            <a:spLocks noGrp="1"/>
-          </p:cNvSpPr>
-          <p:nvPr>
-            <p:ph type="sldImg" idx="2"/>
-          </p:nvPr>
-        </p:nvSpPr>
-        <p:spPr/>
-      </p:sp>
-      <p:sp>
-        <p:nvSpPr>
-          <p:cNvPr id="3" name="Notes Placeholder 2"/>
-          <p:cNvSpPr>
-            <a:spLocks noGrp="1"/>
-          </p:cNvSpPr>
-          <p:nvPr>
-            <p:ph type="body" idx="3" sz="quarter"/>
-          </p:nvPr>
-        </p:nvSpPr>
-        <p:spPr/>
-        <p:txBody>
-          <a:bodyPr/>
-          <a:lstStyle/>
-          <a:p/>
-        </p:txBody>
-      </p:sp>
-      <p:sp>
-        <p:nvSpPr>
-          <p:cNvPr id="4" name="Slide Number Placeholder 3"/>
-          <p:cNvSpPr>
-            <a:spLocks noGrp="1"/>
-          </p:cNvSpPr>
-          <p:nvPr>
-            <p:ph type="sldNum" idx="5" sz="quarter"/>
-          </p:nvPr>
-        </p:nvSpPr>
-        <p:spPr/>
-      </p:sp>
-    </p:spTree>
-  </p:cSld>
-  <p:clrMapOvr>
-    <a:masterClrMapping/>
-  </p:clrMapOvr>
-</p:notes>
-</file>
-
-<file path=ppt/notesSlides/notesSlide5.xml><?xml version="1.0" encoding="utf-8"?>
-<p:notes xmlns:a="http://schemas.openxmlformats.org/drawingml/2006/main" xmlns:p="http://schemas.openxmlformats.org/presentationml/2006/main" xmlns:r="http://schemas.openxmlformats.org/officeDocument/2006/relationships">
-  <p:cSld>
-    <p:spTree>
-      <p:nvGrpSpPr>
-        <p:cNvPr id="1" name=""/>
-        <p:cNvGrpSpPr/>
-        <p:nvPr/>
-      </p:nvGrpSpPr>
-      <p:grpSpPr>
-        <a:xfrm>
-          <a:off x="0" y="0"/>
-          <a:ext cx="0" cy="0"/>
-          <a:chOff x="0" y="0"/>
-          <a:chExt cx="0" cy="0"/>
-        </a:xfrm>
-      </p:grpSpPr>
-      <p:sp>
-        <p:nvSpPr>
-          <p:cNvPr id="2" name="Slide Image Placeholder 1"/>
-          <p:cNvSpPr>
-            <a:spLocks noGrp="1"/>
-          </p:cNvSpPr>
-          <p:nvPr>
-            <p:ph type="sldImg" idx="2"/>
-          </p:nvPr>
-        </p:nvSpPr>
-        <p:spPr/>
-      </p:sp>
-      <p:sp>
-        <p:nvSpPr>
-          <p:cNvPr id="3" name="Notes Placeholder 2"/>
-          <p:cNvSpPr>
-            <a:spLocks noGrp="1"/>
-          </p:cNvSpPr>
-          <p:nvPr>
-            <p:ph type="body" idx="3" sz="quarter"/>
-          </p:nvPr>
-        </p:nvSpPr>
-        <p:spPr/>
-        <p:txBody>
-          <a:bodyPr/>
-          <a:lstStyle/>
-          <a:p/>
-        </p:txBody>
-      </p:sp>
-      <p:sp>
-        <p:nvSpPr>
-          <p:cNvPr id="4" name="Slide Number Placeholder 3"/>
-          <p:cNvSpPr>
-            <a:spLocks noGrp="1"/>
-          </p:cNvSpPr>
-          <p:nvPr>
-            <p:ph type="sldNum" idx="5" sz="quarter"/>
-          </p:nvPr>
-        </p:nvSpPr>
-        <p:spPr/>
-      </p:sp>
-    </p:spTree>
-  </p:cSld>
-  <p:clrMapOvr>
-    <a:masterClrMapping/>
-  </p:clrMapOvr>
-</p:notes>
-</file>
-
-<file path=ppt/notesSlides/notesSlide6.xml><?xml version="1.0" encoding="utf-8"?>
-<p:notes xmlns:a="http://schemas.openxmlformats.org/drawingml/2006/main" xmlns:p="http://schemas.openxmlformats.org/presentationml/2006/main" xmlns:r="http://schemas.openxmlformats.org/officeDocument/2006/relationships">
-  <p:cSld>
-    <p:spTree>
-      <p:nvGrpSpPr>
-        <p:cNvPr id="1" name=""/>
-        <p:cNvGrpSpPr/>
-        <p:nvPr/>
-      </p:nvGrpSpPr>
-      <p:grpSpPr>
-        <a:xfrm>
-          <a:off x="0" y="0"/>
-          <a:ext cx="0" cy="0"/>
-          <a:chOff x="0" y="0"/>
-          <a:chExt cx="0" cy="0"/>
-        </a:xfrm>
-      </p:grpSpPr>
-      <p:sp>
-        <p:nvSpPr>
-          <p:cNvPr id="2" name="Slide Image Placeholder 1"/>
-          <p:cNvSpPr>
-            <a:spLocks noGrp="1"/>
-          </p:cNvSpPr>
-          <p:nvPr>
-            <p:ph type="sldImg" idx="2"/>
-          </p:nvPr>
-        </p:nvSpPr>
-        <p:spPr/>
-      </p:sp>
-      <p:sp>
-        <p:nvSpPr>
-          <p:cNvPr id="3" name="Notes Placeholder 2"/>
-          <p:cNvSpPr>
-            <a:spLocks noGrp="1"/>
-          </p:cNvSpPr>
-          <p:nvPr>
-            <p:ph type="body" idx="3" sz="quarter"/>
-          </p:nvPr>
-        </p:nvSpPr>
-        <p:spPr/>
-        <p:txBody>
-          <a:bodyPr/>
-          <a:lstStyle/>
-          <a:p/>
-        </p:txBody>
-      </p:sp>
-      <p:sp>
-        <p:nvSpPr>
-          <p:cNvPr id="4" name="Slide Number Placeholder 3"/>
-          <p:cNvSpPr>
-            <a:spLocks noGrp="1"/>
-          </p:cNvSpPr>
-          <p:nvPr>
-            <p:ph type="sldNum" idx="5" sz="quarter"/>
-          </p:nvPr>
-        </p:nvSpPr>
-        <p:spPr/>
-      </p:sp>
-    </p:spTree>
-  </p:cSld>
-  <p:clrMapOvr>
-    <a:masterClrMapping/>
-  </p:clrMapOvr>
-</p:notes>
-</file>
-
-<file path=ppt/notesSlides/notesSlide7.xml><?xml version="1.0" encoding="utf-8"?>
-<p:notes xmlns:a="http://schemas.openxmlformats.org/drawingml/2006/main" xmlns:p="http://schemas.openxmlformats.org/presentationml/2006/main" xmlns:r="http://schemas.openxmlformats.org/officeDocument/2006/relationships">
-  <p:cSld>
-    <p:spTree>
-      <p:nvGrpSpPr>
-        <p:cNvPr id="1" name=""/>
-        <p:cNvGrpSpPr/>
-        <p:nvPr/>
-      </p:nvGrpSpPr>
-      <p:grpSpPr>
-        <a:xfrm>
-          <a:off x="0" y="0"/>
-          <a:ext cx="0" cy="0"/>
-          <a:chOff x="0" y="0"/>
-          <a:chExt cx="0" cy="0"/>
-        </a:xfrm>
-      </p:grpSpPr>
-      <p:sp>
-        <p:nvSpPr>
-          <p:cNvPr id="2" name="Slide Image Placeholder 1"/>
-          <p:cNvSpPr>
-            <a:spLocks noGrp="1"/>
-          </p:cNvSpPr>
-          <p:nvPr>
-            <p:ph type="sldImg" idx="2"/>
-          </p:nvPr>
-        </p:nvSpPr>
-        <p:spPr/>
-      </p:sp>
-      <p:sp>
-        <p:nvSpPr>
-          <p:cNvPr id="3" name="Notes Placeholder 2"/>
-          <p:cNvSpPr>
-            <a:spLocks noGrp="1"/>
-          </p:cNvSpPr>
-          <p:nvPr>
-            <p:ph type="body" idx="3" sz="quarter"/>
-          </p:nvPr>
-        </p:nvSpPr>
-        <p:spPr/>
-        <p:txBody>
-          <a:bodyPr/>
-          <a:lstStyle/>
-          <a:p/>
-        </p:txBody>
-      </p:sp>
-      <p:sp>
-        <p:nvSpPr>
-          <p:cNvPr id="4" name="Slide Number Placeholder 3"/>
-          <p:cNvSpPr>
-            <a:spLocks noGrp="1"/>
-          </p:cNvSpPr>
-          <p:nvPr>
-            <p:ph type="sldNum" idx="5" sz="quarter"/>
-          </p:nvPr>
-        </p:nvSpPr>
-        <p:spPr/>
-      </p:sp>
-    </p:spTree>
-  </p:cSld>
-  <p:clrMapOvr>
-    <a:masterClrMapping/>
-  </p:clrMapOvr>
-</p:notes>
-</file>
-
-<file path=ppt/notesSlides/notesSlide8.xml><?xml version="1.0" encoding="utf-8"?>
-<p:notes xmlns:a="http://schemas.openxmlformats.org/drawingml/2006/main" xmlns:p="http://schemas.openxmlformats.org/presentationml/2006/main" xmlns:r="http://schemas.openxmlformats.org/officeDocument/2006/relationships">
-  <p:cSld>
-    <p:spTree>
-      <p:nvGrpSpPr>
-        <p:cNvPr id="1" name=""/>
-        <p:cNvGrpSpPr/>
-        <p:nvPr/>
-      </p:nvGrpSpPr>
-      <p:grpSpPr>
-        <a:xfrm>
-          <a:off x="0" y="0"/>
-          <a:ext cx="0" cy="0"/>
-          <a:chOff x="0" y="0"/>
-          <a:chExt cx="0" cy="0"/>
-        </a:xfrm>
-      </p:grpSpPr>
-      <p:sp>
-        <p:nvSpPr>
-          <p:cNvPr id="2" name="Slide Image Placeholder 1"/>
-          <p:cNvSpPr>
-            <a:spLocks noGrp="1"/>
-          </p:cNvSpPr>
-          <p:nvPr>
-            <p:ph type="sldImg" idx="2"/>
-          </p:nvPr>
-        </p:nvSpPr>
-        <p:spPr/>
-      </p:sp>
-      <p:sp>
-        <p:nvSpPr>
-          <p:cNvPr id="3" name="Notes Placeholder 2"/>
-          <p:cNvSpPr>
-            <a:spLocks noGrp="1"/>
-          </p:cNvSpPr>
-          <p:nvPr>
-            <p:ph type="body" idx="3" sz="quarter"/>
-          </p:nvPr>
-        </p:nvSpPr>
-        <p:spPr/>
-        <p:txBody>
-          <a:bodyPr/>
-          <a:lstStyle/>
-          <a:p/>
-        </p:txBody>
-      </p:sp>
-      <p:sp>
-        <p:nvSpPr>
-          <p:cNvPr id="4" name="Slide Number Placeholder 3"/>
-          <p:cNvSpPr>
-            <a:spLocks noGrp="1"/>
-          </p:cNvSpPr>
-          <p:nvPr>
-            <p:ph type="sldNum" idx="5" sz="quarter"/>
-          </p:nvPr>
-        </p:nvSpPr>
-        <p:spPr/>
-      </p:sp>
-    </p:spTree>
-  </p:cSld>
-  <p:clrMapOvr>
-    <a:masterClrMapping/>
-  </p:clrMapOvr>
-</p:notes>
-</file>
-
-<file path=ppt/notesSlides/notesSlide9.xml><?xml version="1.0" encoding="utf-8"?>
-<p:notes xmlns:a="http://schemas.openxmlformats.org/drawingml/2006/main" xmlns:p="http://schemas.openxmlformats.org/presentationml/2006/main" xmlns:r="http://schemas.openxmlformats.org/officeDocument/2006/relationships">
-  <p:cSld>
-    <p:spTree>
-      <p:nvGrpSpPr>
-        <p:cNvPr id="1" name=""/>
-        <p:cNvGrpSpPr/>
-        <p:nvPr/>
-      </p:nvGrpSpPr>
-      <p:grpSpPr>
-        <a:xfrm>
-          <a:off x="0" y="0"/>
-          <a:ext cx="0" cy="0"/>
-          <a:chOff x="0" y="0"/>
-          <a:chExt cx="0" cy="0"/>
-        </a:xfrm>
-      </p:grpSpPr>
-      <p:sp>
-        <p:nvSpPr>
-          <p:cNvPr id="2" name="Slide Image Placeholder 1"/>
-          <p:cNvSpPr>
-            <a:spLocks noGrp="1"/>
-          </p:cNvSpPr>
-          <p:nvPr>
-            <p:ph type="sldImg" idx="2"/>
-          </p:nvPr>
-        </p:nvSpPr>
-        <p:spPr/>
-      </p:sp>
-      <p:sp>
-        <p:nvSpPr>
-          <p:cNvPr id="3" name="Notes Placeholder 2"/>
-          <p:cNvSpPr>
-            <a:spLocks noGrp="1"/>
-          </p:cNvSpPr>
-          <p:nvPr>
-            <p:ph type="body" idx="3" sz="quarter"/>
-          </p:nvPr>
-        </p:nvSpPr>
-        <p:spPr/>
-        <p:txBody>
-          <a:bodyPr/>
-          <a:lstStyle/>
-          <a:p/>
-        </p:txBody>
-      </p:sp>
-      <p:sp>
-        <p:nvSpPr>
-          <p:cNvPr id="4" name="Slide Number Placeholder 3"/>
-          <p:cNvSpPr>
-            <a:spLocks noGrp="1"/>
-          </p:cNvSpPr>
-          <p:nvPr>
-            <p:ph type="sldNum" idx="5" sz="quarter"/>
-          </p:nvPr>
-        </p:nvSpPr>
-        <p:spPr/>
-      </p:sp>
-    </p:spTree>
-  </p:cSld>
-  <p:clrMapOvr>
-    <a:masterClrMapping/>
-  </p:clrMapOvr>
-</p:notes>
 </file>
 
 <file path=ppt/slideLayouts/slideLayout1.xml><?xml version="1.0" encoding="utf-8"?>

</xml_diff>